<commit_message>
Diagnóstico IA DTS v2: modelo Axon com visual do caderno
Resultados simplificados, delegação com exemplo, prompts e modelos,
direcionador com trilha de vídeos em 4 níveis e mural ajustado.

Co-Authored-By: Claude Opus 5.5 <noreply@anthropic.com>
Claude-Session: https://claude.ai/code/session_01USW4cA4Lskojc22YXjymBu
</commit_message>
<xml_diff>
--- a/diagnostico-ia/DTS_Diagnostico_Nivelamento_IA.pptx
+++ b/diagnostico-ia/DTS_Diagnostico_Nivelamento_IA.pptx
@@ -10,6 +10,7 @@
     <p:sldId id="258" r:id="rId10"/>
     <p:sldId id="259" r:id="rId11"/>
     <p:sldId id="260" r:id="rId12"/>
+    <p:sldId id="261" r:id="rId13"/>
   </p:sldIdLst>
   <p:sldSz cx="12192000" cy="6858000" type="screen4x3"/>
   <p:notesSz cx="6858000" cy="9144000"/>
@@ -506,13 +507,38 @@
           <a:lstStyle/>
           <a:p>
             <a:r>
-              <a:t>33 convidados, 29 iniciaram e 25 concluíram o caderno. Índice consolidado médio de 78,6 (faixa Autonomia), com 10 pessoas já em Multiplicação. O time declarou 64,7 mas demonstrou 84,6: 21 de 25 se subestimam.</a:t>
+              <a:t>Sobre este slide: Capa da devolutiva do Caderno de Nivelamento DTS. O visual segue o caderno que o time respondeu: página azul à esquerda e papel quadriculado à direita. Clique em um item do sumário para ir direto à página.</a:t>
             </a:r>
           </a:p>
           <a:p/>
           <a:p>
             <a:r>
-              <a:t>— Conteúdo da página —</a:t>
+              <a:t>— Conteúdo —</a:t>
+            </a:r>
+          </a:p>
+          <a:p>
+            <a:r>
+              <a:t>ALVAREZ &amp; MARSAL · DTS · NIVELAMENTO IA</a:t>
+            </a:r>
+          </a:p>
+          <a:p>
+            <a:r>
+              <a:t>Caderno de Nivelamento DTS</a:t>
+            </a:r>
+          </a:p>
+          <a:p>
+            <a:r>
+              <a:t>Resultados e próximos passos</a:t>
+            </a:r>
+          </a:p>
+          <a:p>
+            <a:r>
+              <a:t>25 cadernos concluídos. O que descobrimos sobre como o time usa IA hoje, o que falta para delegar a agentes e por onde seguimos a partir de agora.</a:t>
+            </a:r>
+          </a:p>
+          <a:p>
+            <a:r>
+              <a:t>ALVAREZ &amp; MARSAL</a:t>
             </a:r>
           </a:p>
           <a:p>
@@ -522,412 +548,87 @@
           </a:p>
           <a:p>
             <a:r>
+              <a:t>Antes de começar: isto não é um ranking. É uma fotografia do time para decidir juntos os próximos passos.</a:t>
+            </a:r>
+          </a:p>
+          <a:p>
+            <a:r>
               <a:t>01</a:t>
             </a:r>
           </a:p>
           <a:p>
             <a:r>
-              <a:t>Onde estamos</a:t>
-            </a:r>
-          </a:p>
-          <a:p>
-            <a:r>
-              <a:t>O Caderno de Nivelamento cruzou o que cada pessoa diz fazer com IA com o que ela demonstra em 7 brincadeiras. Este é o retrato do time.</a:t>
-            </a:r>
-          </a:p>
-          <a:p>
-            <a:r>
-              <a:t>“O time já opera em Autonomia, mas ainda se enxerga em Evolução.”</a:t>
-            </a:r>
-          </a:p>
-          <a:p>
-            <a:r>
-              <a:t>CADERNO DTS · OUT 2026 · N = 25</a:t>
-            </a:r>
-          </a:p>
-          <a:p>
-            <a:r>
-              <a:t>ADOÇÃO DO CADERNO</a:t>
-            </a:r>
-          </a:p>
-          <a:p>
-            <a:r>
-              <a:t>CONVIDADOS</a:t>
-            </a:r>
-          </a:p>
-          <a:p>
-            <a:r>
-              <a:t>33</a:t>
-            </a:r>
-          </a:p>
-          <a:p>
-            <a:r>
-              <a:t>Encontro com a Galera · DTS</a:t>
-            </a:r>
-          </a:p>
-          <a:p>
-            <a:r>
-              <a:t>INICIARAM</a:t>
-            </a:r>
-          </a:p>
-          <a:p>
-            <a:r>
-              <a:t>29 88%</a:t>
-            </a:r>
-          </a:p>
-          <a:p>
-            <a:r>
-              <a:t>abriram e responderam ao menos 1 página</a:t>
-            </a:r>
-          </a:p>
-          <a:p>
-            <a:r>
-              <a:t>CONCLUÍRAM</a:t>
-            </a:r>
-          </a:p>
-          <a:p>
-            <a:r>
-              <a:t>25 76%</a:t>
-            </a:r>
-          </a:p>
-          <a:p>
-            <a:r>
-              <a:t>fizeram as 7 páginas (86% de quem começou)</a:t>
-            </a:r>
-          </a:p>
-          <a:p>
-            <a:r>
-              <a:t>TEMPO MEDIANO</a:t>
-            </a:r>
-          </a:p>
-          <a:p>
-            <a:r>
-              <a:t>12 min</a:t>
-            </a:r>
-          </a:p>
-          <a:p>
-            <a:r>
-              <a:t>entre quem fez de uma vez (previsto: 6 min)</a:t>
-            </a:r>
-          </a:p>
-          <a:p>
-            <a:r>
-              <a:t>ÍNDICE CONSOLIDADO</a:t>
-            </a:r>
-          </a:p>
-          <a:p>
-            <a:r>
-              <a:t>78,6</a:t>
-            </a:r>
-          </a:p>
-          <a:p>
-            <a:r>
-              <a:t>30% declarado + 70% demonstrado · faixa Autonomia</a:t>
-            </a:r>
-          </a:p>
-          <a:p>
-            <a:r>
-              <a:t>FUNIL DE ADOÇÃO</a:t>
-            </a:r>
-          </a:p>
-          <a:p>
-            <a:r>
-              <a:t>Convidados</a:t>
-            </a:r>
-          </a:p>
-          <a:p>
-            <a:r>
-              <a:t>33</a:t>
-            </a:r>
-          </a:p>
-          <a:p>
-            <a:r>
-              <a:t>100%</a:t>
-            </a:r>
-          </a:p>
-          <a:p>
-            <a:r>
-              <a:t>Aceitaram convite</a:t>
-            </a:r>
-          </a:p>
-          <a:p>
-            <a:r>
-              <a:t>18</a:t>
-            </a:r>
-          </a:p>
-          <a:p>
-            <a:r>
-              <a:t>55%</a:t>
-            </a:r>
-          </a:p>
-          <a:p>
-            <a:r>
-              <a:t>Iniciaram caderno</a:t>
-            </a:r>
-          </a:p>
-          <a:p>
-            <a:r>
-              <a:t>29</a:t>
-            </a:r>
-          </a:p>
-          <a:p>
-            <a:r>
-              <a:t>88%</a:t>
-            </a:r>
-          </a:p>
-          <a:p>
-            <a:r>
-              <a:t>Concluíram</a:t>
-            </a:r>
-          </a:p>
-          <a:p>
-            <a:r>
-              <a:t>25</a:t>
-            </a:r>
-          </a:p>
-          <a:p>
-            <a:r>
-              <a:t>76%</a:t>
-            </a:r>
-          </a:p>
-          <a:p>
-            <a:r>
-              <a:t>4</a:t>
-            </a:r>
-          </a:p>
-          <a:p>
-            <a:r>
-              <a:t>pararam no meio</a:t>
-            </a:r>
-          </a:p>
-          <a:p>
-            <a:r>
-              <a:t>(2 delas na pág. 6 de 7)</a:t>
-            </a:r>
-          </a:p>
-          <a:p>
-            <a:r>
-              <a:t>4</a:t>
-            </a:r>
-          </a:p>
-          <a:p>
-            <a:r>
-              <a:t>ainda não abriram</a:t>
-            </a:r>
-          </a:p>
-          <a:p>
-            <a:r>
-              <a:t>o caderno</a:t>
-            </a:r>
-          </a:p>
-          <a:p>
-            <a:r>
-              <a:t>11/13</a:t>
-            </a:r>
-          </a:p>
-          <a:p>
-            <a:r>
-              <a:t>que nem responderam o convite… concluíram</a:t>
-            </a:r>
-          </a:p>
-          <a:p>
-            <a:r>
-              <a:t>DISTRIBUIÇÃO POR FAIXA · COMO SE VEEM × COMO OPERAM</a:t>
-            </a:r>
-          </a:p>
-          <a:p>
-            <a:r>
-              <a:t>0</a:t>
-            </a:r>
-          </a:p>
-          <a:p>
-            <a:r>
-              <a:t>0</a:t>
-            </a:r>
-          </a:p>
-          <a:p>
-            <a:r>
-              <a:t>PONTO DE PARTIDA</a:t>
-            </a:r>
-          </a:p>
-          <a:p>
-            <a:r>
-              <a:t>0–20</a:t>
-            </a:r>
-          </a:p>
-          <a:p>
-            <a:r>
-              <a:t>4</a:t>
-            </a:r>
-          </a:p>
-          <a:p>
-            <a:r>
-              <a:t>0</a:t>
-            </a:r>
-          </a:p>
-          <a:p>
-            <a:r>
-              <a:t>EXPLORAÇÃO</a:t>
-            </a:r>
-          </a:p>
-          <a:p>
-            <a:r>
-              <a:t>21–40</a:t>
-            </a:r>
-          </a:p>
-          <a:p>
-            <a:r>
-              <a:t>7</a:t>
-            </a:r>
-          </a:p>
-          <a:p>
-            <a:r>
-              <a:t>1</a:t>
-            </a:r>
-          </a:p>
-          <a:p>
-            <a:r>
-              <a:t>EVOLUÇÃO</a:t>
-            </a:r>
-          </a:p>
-          <a:p>
-            <a:r>
-              <a:t>41–60</a:t>
-            </a:r>
-          </a:p>
-          <a:p>
-            <a:r>
-              <a:t>7</a:t>
-            </a:r>
-          </a:p>
-          <a:p>
-            <a:r>
-              <a:t>14</a:t>
-            </a:r>
-          </a:p>
-          <a:p>
-            <a:r>
-              <a:t>AUTONOMIA</a:t>
-            </a:r>
-          </a:p>
-          <a:p>
-            <a:r>
-              <a:t>61–80</a:t>
-            </a:r>
-          </a:p>
-          <a:p>
-            <a:r>
-              <a:t>7</a:t>
-            </a:r>
-          </a:p>
-          <a:p>
-            <a:r>
-              <a:t>10</a:t>
-            </a:r>
-          </a:p>
-          <a:p>
-            <a:r>
-              <a:t>MULTIPLICAÇÃO</a:t>
-            </a:r>
-          </a:p>
-          <a:p>
-            <a:r>
-              <a:t>81–100</a:t>
-            </a:r>
-          </a:p>
-          <a:p>
-            <a:r>
-              <a:t>Faixa declarada (autopercepção)</a:t>
-            </a:r>
-          </a:p>
-          <a:p>
-            <a:r>
-              <a:t>Faixa pelo índice consolidado</a:t>
-            </a:r>
-          </a:p>
-          <a:p>
-            <a:r>
-              <a:t>Achado nº 1</a:t>
-            </a:r>
-          </a:p>
-          <a:p>
-            <a:r>
-              <a:t>21 de 25 pessoas demonstraram mais do que declararam. Distância média: +20 pontos (64,7 → 84,6).</a:t>
-            </a:r>
-          </a:p>
-          <a:p>
-            <a:r>
-              <a:t>Leitura: o problema não é saber usar. É confiança, método e escala.</a:t>
-            </a:r>
-          </a:p>
-          <a:p>
-            <a:r>
-              <a:t>TERMÔMETRO DO TIME · ÍNDICE CONSOLIDADO DE CADA PESSOA (ANÔNIMO)</a:t>
-            </a:r>
-          </a:p>
-          <a:p>
-            <a:r>
-              <a:t>PONTO DE PARTIDA</a:t>
-            </a:r>
-          </a:p>
-          <a:p>
-            <a:r>
-              <a:t>EXPLORAÇÃO</a:t>
-            </a:r>
-          </a:p>
-          <a:p>
-            <a:r>
-              <a:t>EVOLUÇÃO</a:t>
-            </a:r>
-          </a:p>
-          <a:p>
-            <a:r>
-              <a:t>AUTONOMIA</a:t>
-            </a:r>
-          </a:p>
-          <a:p>
-            <a:r>
-              <a:t>MULTIPLICAÇÃO</a:t>
-            </a:r>
-          </a:p>
-          <a:p>
-            <a:r>
-              <a:t>média 78,6</a:t>
-            </a:r>
-          </a:p>
-          <a:p>
-            <a:r>
-              <a:t>meta 85</a:t>
-            </a:r>
-          </a:p>
-          <a:p>
-            <a:r>
-              <a:t>0</a:t>
-            </a:r>
-          </a:p>
-          <a:p>
-            <a:r>
-              <a:t>20</a:t>
-            </a:r>
-          </a:p>
-          <a:p>
-            <a:r>
-              <a:t>40</a:t>
-            </a:r>
-          </a:p>
-          <a:p>
-            <a:r>
-              <a:t>60</a:t>
-            </a:r>
-          </a:p>
-          <a:p>
-            <a:r>
-              <a:t>80</a:t>
-            </a:r>
-          </a:p>
-          <a:p>
-            <a:r>
-              <a:t>100</a:t>
+              <a:t>Resultados</a:t>
+            </a:r>
+          </a:p>
+          <a:p>
+            <a:r>
+              <a:t>onde estamos</a:t>
+            </a:r>
+          </a:p>
+          <a:p>
+            <a:r>
+              <a:t>02</a:t>
+            </a:r>
+          </a:p>
+          <a:p>
+            <a:r>
+              <a:t>Delegar</a:t>
+            </a:r>
+          </a:p>
+          <a:p>
+            <a:r>
+              <a:t>pedir × delegar</a:t>
+            </a:r>
+          </a:p>
+          <a:p>
+            <a:r>
+              <a:t>03</a:t>
+            </a:r>
+          </a:p>
+          <a:p>
+            <a:r>
+              <a:t>Prompt e modelos</a:t>
+            </a:r>
+          </a:p>
+          <a:p>
+            <a:r>
+              <a:t>5 peças + modelos</a:t>
+            </a:r>
+          </a:p>
+          <a:p>
+            <a:r>
+              <a:t>04</a:t>
+            </a:r>
+          </a:p>
+          <a:p>
+            <a:r>
+              <a:t>Para onde vamos</a:t>
+            </a:r>
+          </a:p>
+          <a:p>
+            <a:r>
+              <a:t>direcionador + trilha</a:t>
+            </a:r>
+          </a:p>
+          <a:p>
+            <a:r>
+              <a:t>05</a:t>
+            </a:r>
+          </a:p>
+          <a:p>
+            <a:r>
+              <a:t>Mural</a:t>
+            </a:r>
+          </a:p>
+          <a:p>
+            <a:r>
+              <a:t>retrato falado</a:t>
+            </a:r>
+          </a:p>
+          <a:p>
+            <a:r>
+              <a:t>DOCUMENTO PARA DISCUSSÃO · OUT 2026</a:t>
             </a:r>
           </a:p>
         </p:txBody>
@@ -997,53 +698,380 @@
           <a:lstStyle/>
           <a:p>
             <a:r>
-              <a:t>Por dimensão: Skills &amp; Métodos (96,9) e reutilização (88) são os pontos fortes demonstrados. O gargalo é a maturidade agêntica (52,2). FLOWS e Métodos são os itens de menor uso declarado. No retrato falado, quem reescreveu o prompt subiu de 63 para 87 pontos.</a:t>
+              <a:t>Sobre este slide: Índice consolidado: combina o que cada pessoa disse fazer com o que ela demonstrou nas 6 brincadeiras do caderno. As brincadeiras pesam mais. </a:t>
             </a:r>
           </a:p>
           <a:p/>
           <a:p>
             <a:r>
-              <a:t>— Conteúdo da página —</a:t>
-            </a:r>
-          </a:p>
-          <a:p>
-            <a:r>
-              <a:t>DIGITAL &amp; TECHNOLOGY SERVICES</a:t>
-            </a:r>
-          </a:p>
-          <a:p>
-            <a:r>
-              <a:t>02</a:t>
-            </a:r>
-          </a:p>
-          <a:p>
-            <a:r>
-              <a:t>O que o caderno revelou</a:t>
-            </a:r>
-          </a:p>
-          <a:p>
-            <a:r>
-              <a:t>8 dimensões de maturidade, 6 perguntas de uso e 5 brincadeiras de demonstração. Os pontos fortes estão claros e há um gargalo bem definido.</a:t>
-            </a:r>
-          </a:p>
-          <a:p>
-            <a:r>
-              <a:t>“Sabemos pedir. Ainda não sabemos delegar para agentes.”</a:t>
-            </a:r>
-          </a:p>
-          <a:p>
-            <a:r>
-              <a:t>FONTE · REGISTROS DO CADERNO (25 CONCLUÍDOS)</a:t>
-            </a:r>
-          </a:p>
-          <a:p>
-            <a:r>
-              <a:t>Forte em Skills, Prompt e reutilização. O gargalo é a maturidade agêntica (52): o próximo salto de produtividade.</a:t>
-            </a:r>
-          </a:p>
-          <a:p>
-            <a:r>
-              <a:t>MATURIDADE POR DIMENSÃO (0–100)</a:t>
+              <a:t>Adoção: considera os 33 convidados da lista do encontro. </a:t>
+            </a:r>
+          </a:p>
+          <a:p/>
+          <a:p>
+            <a:r>
+              <a:t>Faixas: Ponto de partida (0–20), Exploração (21–40), Evolução (41–60), Autonomia (61–80) e Multiplicação (81–100).</a:t>
+            </a:r>
+          </a:p>
+          <a:p/>
+          <a:p>
+            <a:r>
+              <a:t>— Conteúdo —</a:t>
+            </a:r>
+          </a:p>
+          <a:p>
+            <a:r>
+              <a:t>ALVAREZ &amp; MARSAL</a:t>
+            </a:r>
+          </a:p>
+          <a:p>
+            <a:r>
+              <a:t>DTS · NIVELAMENTO IA</a:t>
+            </a:r>
+          </a:p>
+          <a:p>
+            <a:r>
+              <a:t>RESULTADOS</a:t>
+            </a:r>
+          </a:p>
+          <a:p>
+            <a:r>
+              <a:t>Parte 1 · Onde DTS está hoje</a:t>
+            </a:r>
+          </a:p>
+          <a:p>
+            <a:r>
+              <a:t>Diagnóstico IA · DTS</a:t>
+            </a:r>
+          </a:p>
+          <a:p>
+            <a:r>
+              <a:t>1/5</a:t>
+            </a:r>
+          </a:p>
+          <a:p>
+            <a:r>
+              <a:t>RESULTADO DO CADERNO · ONDE ESTAMOS</a:t>
+            </a:r>
+          </a:p>
+          <a:p>
+            <a:r>
+              <a:t>25 cadernos concluídos · 33 convidados</a:t>
+            </a:r>
+          </a:p>
+          <a:p>
+            <a:r>
+              <a:t>ÍNDICE CONSOLIDADO DTS</a:t>
+            </a:r>
+          </a:p>
+          <a:p>
+            <a:r>
+              <a:t>FAIXA AUTONOMIA</a:t>
+            </a:r>
+          </a:p>
+          <a:p>
+            <a:r>
+              <a:t>78,6%</a:t>
+            </a:r>
+          </a:p>
+          <a:p>
+            <a:r>
+              <a:t>O time já usa IA com independência.</a:t>
+            </a:r>
+          </a:p>
+          <a:p>
+            <a:r>
+              <a:t>Usa Claude, FLOWS e Skills no dia a dia sem depender de ajuda. O próximo degrau, Multiplicação (81%+), é transformar esse uso em Skills, Métodos e agentes que o time inteiro reutiliza.</a:t>
+            </a:r>
+          </a:p>
+          <a:p>
+            <a:r>
+              <a:t>DTS 78,6</a:t>
+            </a:r>
+          </a:p>
+          <a:p>
+            <a:r>
+              <a:t>0</a:t>
+            </a:r>
+          </a:p>
+          <a:p>
+            <a:r>
+              <a:t>20</a:t>
+            </a:r>
+          </a:p>
+          <a:p>
+            <a:r>
+              <a:t>40</a:t>
+            </a:r>
+          </a:p>
+          <a:p>
+            <a:r>
+              <a:t>60</a:t>
+            </a:r>
+          </a:p>
+          <a:p>
+            <a:r>
+              <a:t>80</a:t>
+            </a:r>
+          </a:p>
+          <a:p>
+            <a:r>
+              <a:t>100</a:t>
+            </a:r>
+          </a:p>
+          <a:p>
+            <a:r>
+              <a:t>Termômetro do time: cada traço é uma pessoa · laranja = já em Multiplicação</a:t>
+            </a:r>
+          </a:p>
+          <a:p>
+            <a:r>
+              <a:t>ADOÇÃO DO CADERNO</a:t>
+            </a:r>
+          </a:p>
+          <a:p>
+            <a:r>
+              <a:t>8 PESSOAS FORA</a:t>
+            </a:r>
+          </a:p>
+          <a:p>
+            <a:r>
+              <a:t>Convidados</a:t>
+            </a:r>
+          </a:p>
+          <a:p>
+            <a:r>
+              <a:t>33</a:t>
+            </a:r>
+          </a:p>
+          <a:p>
+            <a:r>
+              <a:t>100%</a:t>
+            </a:r>
+          </a:p>
+          <a:p>
+            <a:r>
+              <a:t>Iniciaram</a:t>
+            </a:r>
+          </a:p>
+          <a:p>
+            <a:r>
+              <a:t>29</a:t>
+            </a:r>
+          </a:p>
+          <a:p>
+            <a:r>
+              <a:t>88%</a:t>
+            </a:r>
+          </a:p>
+          <a:p>
+            <a:r>
+              <a:t>Concluíram</a:t>
+            </a:r>
+          </a:p>
+          <a:p>
+            <a:r>
+              <a:t>25</a:t>
+            </a:r>
+          </a:p>
+          <a:p>
+            <a:r>
+              <a:t>76%</a:t>
+            </a:r>
+          </a:p>
+          <a:p>
+            <a:r>
+              <a:t>Não concluíram</a:t>
+            </a:r>
+          </a:p>
+          <a:p>
+            <a:r>
+              <a:t>8</a:t>
+            </a:r>
+          </a:p>
+          <a:p>
+            <a:r>
+              <a:t>24%</a:t>
+            </a:r>
+          </a:p>
+          <a:p>
+            <a:r>
+              <a:t>4</a:t>
+            </a:r>
+          </a:p>
+          <a:p>
+            <a:r>
+              <a:t>pararam no meio</a:t>
+            </a:r>
+          </a:p>
+          <a:p>
+            <a:r>
+              <a:t>4</a:t>
+            </a:r>
+          </a:p>
+          <a:p>
+            <a:r>
+              <a:t>nem abriram</a:t>
+            </a:r>
+          </a:p>
+          <a:p>
+            <a:r>
+              <a:t>85%</a:t>
+            </a:r>
+          </a:p>
+          <a:p>
+            <a:r>
+              <a:t>dos que ignoraram o convite concluíram</a:t>
+            </a:r>
+          </a:p>
+          <a:p>
+            <a:r>
+              <a:t>ONDE DTS SE ENCONTRA</a:t>
+            </a:r>
+          </a:p>
+          <a:p>
+            <a:r>
+              <a:t>pessoas por faixa</a:t>
+            </a:r>
+          </a:p>
+          <a:p>
+            <a:r>
+              <a:t>0</a:t>
+            </a:r>
+          </a:p>
+          <a:p>
+            <a:r>
+              <a:t>PONTO DE PARTIDA</a:t>
+            </a:r>
+          </a:p>
+          <a:p>
+            <a:r>
+              <a:t>0–20</a:t>
+            </a:r>
+          </a:p>
+          <a:p>
+            <a:r>
+              <a:t>0</a:t>
+            </a:r>
+          </a:p>
+          <a:p>
+            <a:r>
+              <a:t>EXPLORAÇÃO</a:t>
+            </a:r>
+          </a:p>
+          <a:p>
+            <a:r>
+              <a:t>21–40</a:t>
+            </a:r>
+          </a:p>
+          <a:p>
+            <a:r>
+              <a:t>1</a:t>
+            </a:r>
+          </a:p>
+          <a:p>
+            <a:r>
+              <a:t>EVOLUÇÃO</a:t>
+            </a:r>
+          </a:p>
+          <a:p>
+            <a:r>
+              <a:t>41–60</a:t>
+            </a:r>
+          </a:p>
+          <a:p>
+            <a:r>
+              <a:t>DTS · 78,6</a:t>
+            </a:r>
+          </a:p>
+          <a:p>
+            <a:r>
+              <a:t>14</a:t>
+            </a:r>
+          </a:p>
+          <a:p>
+            <a:r>
+              <a:t>AUTONOMIA</a:t>
+            </a:r>
+          </a:p>
+          <a:p>
+            <a:r>
+              <a:t>61–80</a:t>
+            </a:r>
+          </a:p>
+          <a:p>
+            <a:r>
+              <a:t>PRÓXIMO DEGRAU</a:t>
+            </a:r>
+          </a:p>
+          <a:p>
+            <a:r>
+              <a:t>10</a:t>
+            </a:r>
+          </a:p>
+          <a:p>
+            <a:r>
+              <a:t>MULTIPLICAÇÃO</a:t>
+            </a:r>
+          </a:p>
+          <a:p>
+            <a:r>
+              <a:t>81–100</a:t>
+            </a:r>
+          </a:p>
+          <a:p>
+            <a:r>
+              <a:t>24 de 25 pessoas já estão em Autonomia ou Multiplicação. Ninguém ficou nas duas primeiras faixas.</a:t>
+            </a:r>
+          </a:p>
+          <a:p>
+            <a:r>
+              <a:t>ACHADO Nº 1 · O MAIS IMPORTANTE</a:t>
+            </a:r>
+          </a:p>
+          <a:p>
+            <a:r>
+              <a:t>O time sabe mais do que acredita saber.</a:t>
+            </a:r>
+          </a:p>
+          <a:p>
+            <a:r>
+              <a:t>21 de 25 pessoas demonstraram nas brincadeiras mais do que declararam no início. A distância média é de 20 pontos.</a:t>
+            </a:r>
+          </a:p>
+          <a:p>
+            <a:r>
+              <a:t>Ou seja, o desafio de DTS não é capacidade, é confiança e hábito. Quem se subestima não compartilha, não vira referência e não propõe IA para o cliente. Por isso o próximo passo é prática visível (FLOWS e Skills em todo projeto), e não mais teoria.</a:t>
+            </a:r>
+          </a:p>
+          <a:p>
+            <a:r>
+              <a:t>64,7</a:t>
+            </a:r>
+          </a:p>
+          <a:p>
+            <a:r>
+              <a:t>DECLARADO</a:t>
+            </a:r>
+          </a:p>
+          <a:p>
+            <a:r>
+              <a:t>+20 →</a:t>
+            </a:r>
+          </a:p>
+          <a:p>
+            <a:r>
+              <a:t>84,6</a:t>
+            </a:r>
+          </a:p>
+          <a:p>
+            <a:r>
+              <a:t>DEMONSTRADO</a:t>
+            </a:r>
+          </a:p>
+          <a:p>
+            <a:r>
+              <a:t>ONDE A DISTÂNCIA É MAIOR</a:t>
             </a:r>
           </a:p>
           <a:p>
@@ -1053,7 +1081,7 @@
           </a:p>
           <a:p>
             <a:r>
-              <a:t>96,9</a:t>
+              <a:t>+35</a:t>
             </a:r>
           </a:p>
           <a:p>
@@ -1063,462 +1091,32 @@
           </a:p>
           <a:p>
             <a:r>
-              <a:t>88,0</a:t>
-            </a:r>
-          </a:p>
-          <a:p>
-            <a:r>
-              <a:t>Prompt &amp; Contexto</a:t>
-            </a:r>
-          </a:p>
-          <a:p>
-            <a:r>
-              <a:t>87,2</a:t>
-            </a:r>
-          </a:p>
-          <a:p>
-            <a:r>
-              <a:t>Fluxo de trabalho</a:t>
-            </a:r>
-          </a:p>
-          <a:p>
-            <a:r>
-              <a:t>81,9</a:t>
-            </a:r>
-          </a:p>
-          <a:p>
-            <a:r>
-              <a:t>Criação &amp; compartilhamento</a:t>
-            </a:r>
-          </a:p>
-          <a:p>
-            <a:r>
-              <a:t>81,2</a:t>
-            </a:r>
-          </a:p>
-          <a:p>
-            <a:r>
-              <a:t>Compreensão semântica</a:t>
-            </a:r>
-          </a:p>
-          <a:p>
-            <a:r>
-              <a:t>78,3</a:t>
-            </a:r>
-          </a:p>
-          <a:p>
-            <a:r>
-              <a:t>Uso do ecossistema</a:t>
-            </a:r>
-          </a:p>
-          <a:p>
-            <a:r>
-              <a:t>72,7</a:t>
-            </a:r>
-          </a:p>
-          <a:p>
-            <a:r>
-              <a:t>Maturidade agêntica</a:t>
-            </a:r>
-          </a:p>
-          <a:p>
-            <a:r>
-              <a:t>52,2</a:t>
-            </a:r>
-          </a:p>
-          <a:p>
-            <a:r>
-              <a:t>Declarado</a:t>
-            </a:r>
-          </a:p>
-          <a:p>
-            <a:r>
-              <a:t>Demonstrado</a:t>
-            </a:r>
-          </a:p>
-          <a:p>
-            <a:r>
-              <a:t>Gargalo</a:t>
-            </a:r>
-          </a:p>
-          <a:p>
-            <a:r>
-              <a:t>linhas: limites das 5 faixas</a:t>
-            </a:r>
-          </a:p>
-          <a:p>
-            <a:r>
-              <a:t>P07 · RETRATO FALADO · ESTRUTURA DO PROMPT (17 QUE REESCREVERAM)</a:t>
-            </a:r>
-          </a:p>
-          <a:p>
-            <a:r>
-              <a:t>1º rascunho</a:t>
-            </a:r>
-          </a:p>
-          <a:p>
-            <a:r>
-              <a:t>63</a:t>
-            </a:r>
-          </a:p>
-          <a:p>
-            <a:r>
-              <a:t>2º rascunho</a:t>
-            </a:r>
-          </a:p>
-          <a:p>
-            <a:r>
-              <a:t>87</a:t>
-            </a:r>
-          </a:p>
-          <a:p>
-            <a:r>
-              <a:t>O que mais faltava no 1º rascunho: contexto/uso da imagem e resultado esperado (formato, enquadramento).</a:t>
-            </a:r>
-          </a:p>
-          <a:p>
-            <a:r>
-              <a:t>PÁGINA 01 · USO DECLARADO (Nº DE PESSOAS POR NÍVEL)</a:t>
-            </a:r>
-          </a:p>
-          <a:p>
-            <a:r>
-              <a:t>NÍVEL 0</a:t>
-            </a:r>
-          </a:p>
-          <a:p>
-            <a:r>
-              <a:t>NÍVEL 1</a:t>
-            </a:r>
-          </a:p>
-          <a:p>
-            <a:r>
-              <a:t>NÍVEL 2</a:t>
-            </a:r>
-          </a:p>
-          <a:p>
-            <a:r>
-              <a:t>NÍVEL 3</a:t>
-            </a:r>
-          </a:p>
-          <a:p>
-            <a:r>
-              <a:t>ÍNDICE</a:t>
-            </a:r>
-          </a:p>
-          <a:p>
-            <a:r>
-              <a:t>Claude Desktop</a:t>
-            </a:r>
-          </a:p>
-          <a:p>
-            <a:r>
-              <a:t>0</a:t>
-            </a:r>
-          </a:p>
-          <a:p>
-            <a:r>
-              <a:t>1</a:t>
-            </a:r>
-          </a:p>
-          <a:p>
-            <a:r>
-              <a:t>7</a:t>
-            </a:r>
-          </a:p>
-          <a:p>
-            <a:r>
-              <a:t>17</a:t>
-            </a:r>
-          </a:p>
-          <a:p>
-            <a:r>
-              <a:t>88</a:t>
-            </a:r>
-          </a:p>
-          <a:p>
-            <a:r>
-              <a:t>Skills</a:t>
-            </a:r>
-          </a:p>
-          <a:p>
-            <a:r>
-              <a:t>1</a:t>
-            </a:r>
-          </a:p>
-          <a:p>
-            <a:r>
-              <a:t>5</a:t>
-            </a:r>
-          </a:p>
-          <a:p>
-            <a:r>
-              <a:t>6</a:t>
-            </a:r>
-          </a:p>
-          <a:p>
-            <a:r>
-              <a:t>13</a:t>
-            </a:r>
-          </a:p>
-          <a:p>
-            <a:r>
-              <a:t>75</a:t>
-            </a:r>
-          </a:p>
-          <a:p>
-            <a:r>
-              <a:t>Reutilização</a:t>
-            </a:r>
-          </a:p>
-          <a:p>
-            <a:r>
-              <a:t>0</a:t>
-            </a:r>
-          </a:p>
-          <a:p>
-            <a:r>
-              <a:t>5</a:t>
-            </a:r>
-          </a:p>
-          <a:p>
-            <a:r>
-              <a:t>14</a:t>
-            </a:r>
-          </a:p>
-          <a:p>
-            <a:r>
-              <a:t>6</a:t>
-            </a:r>
-          </a:p>
-          <a:p>
-            <a:r>
-              <a:t>68</a:t>
-            </a:r>
-          </a:p>
-          <a:p>
-            <a:r>
-              <a:t>Compartilhamento</a:t>
-            </a:r>
-          </a:p>
-          <a:p>
-            <a:r>
-              <a:t>4</a:t>
-            </a:r>
-          </a:p>
-          <a:p>
-            <a:r>
-              <a:t>4</a:t>
-            </a:r>
-          </a:p>
-          <a:p>
-            <a:r>
-              <a:t>4</a:t>
-            </a:r>
-          </a:p>
-          <a:p>
-            <a:r>
-              <a:t>13</a:t>
-            </a:r>
-          </a:p>
-          <a:p>
-            <a:r>
-              <a:t>68</a:t>
-            </a:r>
-          </a:p>
-          <a:p>
-            <a:r>
-              <a:t>FLOWS</a:t>
-            </a:r>
-          </a:p>
-          <a:p>
-            <a:r>
-              <a:t>2</a:t>
-            </a:r>
-          </a:p>
-          <a:p>
-            <a:r>
-              <a:t>5</a:t>
-            </a:r>
-          </a:p>
-          <a:p>
-            <a:r>
-              <a:t>16</a:t>
-            </a:r>
-          </a:p>
-          <a:p>
-            <a:r>
-              <a:t>2</a:t>
-            </a:r>
-          </a:p>
-          <a:p>
-            <a:r>
-              <a:t>57</a:t>
-            </a:r>
-          </a:p>
-          <a:p>
-            <a:r>
-              <a:t>Métodos</a:t>
-            </a:r>
-          </a:p>
-          <a:p>
-            <a:r>
-              <a:t>6</a:t>
-            </a:r>
-          </a:p>
-          <a:p>
-            <a:r>
-              <a:t>7</a:t>
-            </a:r>
-          </a:p>
-          <a:p>
-            <a:r>
-              <a:t>6</a:t>
-            </a:r>
-          </a:p>
-          <a:p>
-            <a:r>
-              <a:t>6</a:t>
-            </a:r>
-          </a:p>
-          <a:p>
-            <a:r>
-              <a:t>49</a:t>
-            </a:r>
-          </a:p>
-          <a:p>
-            <a:r>
-              <a:t>0 = não uso · 1 = conheço · 2 = uso às vezes · 3 = uso com autonomia/compartilho</a:t>
-            </a:r>
-          </a:p>
-          <a:p>
-            <a:r>
-              <a:t>P04 · CAMINHO DE TRABALHO</a:t>
-            </a:r>
-          </a:p>
-          <a:p>
-            <a:r>
-              <a:t>C · FLOWS → verificar → adaptar</a:t>
-            </a:r>
-          </a:p>
-          <a:p>
-            <a:r>
-              <a:t>18</a:t>
-            </a:r>
-          </a:p>
-          <a:p>
-            <a:r>
-              <a:t>A · Claude direto → ajustes</a:t>
-            </a:r>
-          </a:p>
-          <a:p>
-            <a:r>
-              <a:t>5</a:t>
-            </a:r>
-          </a:p>
-          <a:p>
-            <a:r>
-              <a:t>B · arquivo antigo → adaptar</a:t>
-            </a:r>
-          </a:p>
-          <a:p>
-            <a:r>
-              <a:t>1</a:t>
-            </a:r>
-          </a:p>
-          <a:p>
-            <a:r>
-              <a:t>D · Método → Skill → Agente</a:t>
-            </a:r>
-          </a:p>
-          <a:p>
-            <a:r>
-              <a:t>1</a:t>
-            </a:r>
-          </a:p>
-          <a:p>
-            <a:r>
-              <a:t>P06 · PEÇAS DO PROMPT MAIS ESCOLHIDAS</a:t>
-            </a:r>
-          </a:p>
-          <a:p>
-            <a:r>
-              <a:t>Contexto</a:t>
-            </a:r>
-          </a:p>
-          <a:p>
-            <a:r>
-              <a:t>21</a:t>
-            </a:r>
-          </a:p>
-          <a:p>
-            <a:r>
-              <a:t>Objetivo</a:t>
-            </a:r>
-          </a:p>
-          <a:p>
-            <a:r>
-              <a:t>16</a:t>
-            </a:r>
-          </a:p>
-          <a:p>
-            <a:r>
-              <a:t>Público</a:t>
-            </a:r>
-          </a:p>
-          <a:p>
-            <a:r>
-              <a:t>14</a:t>
-            </a:r>
-          </a:p>
-          <a:p>
-            <a:r>
-              <a:t>Formato de saída</a:t>
-            </a:r>
-          </a:p>
-          <a:p>
-            <a:r>
-              <a:t>11</a:t>
-            </a:r>
-          </a:p>
-          <a:p>
-            <a:r>
-              <a:t>Referências</a:t>
-            </a:r>
-          </a:p>
-          <a:p>
-            <a:r>
-              <a:t>11</a:t>
-            </a:r>
-          </a:p>
-          <a:p>
-            <a:r>
-              <a:t>Métodos é o elo fraco do uso</a:t>
-            </a:r>
-          </a:p>
-          <a:p>
-            <a:r>
-              <a:t>13 de 25 usam pouco ou nada de Métodos (índice 49). FLOWS tem uso mediano (57). A base existe, mas o hábito ainda não.</a:t>
-            </a:r>
-          </a:p>
-          <a:p>
-            <a:r>
-              <a:t>72% passam pelo FLOWS antes, só 4% orquestram</a:t>
-            </a:r>
-          </a:p>
-          <a:p>
-            <a:r>
-              <a:t>18 pessoas verificam o FLOWS e adaptam. Só 1 encadeia Método → Skill → Agente. Ainda é reuso, não automação.</a:t>
-            </a:r>
-          </a:p>
-          <a:p>
-            <a:r>
-              <a:t>Aprendem no ato: +24 pontos</a:t>
-            </a:r>
-          </a:p>
-          <a:p>
-            <a:r>
-              <a:t>17 pessoas reescreveram o prompt do retrato falado. A estrutura subiu de 63 para 87. Basta um empurrão com feedback.</a:t>
+              <a:t>+20</a:t>
+            </a:r>
+          </a:p>
+          <a:p>
+            <a:r>
+              <a:t>Criar &amp; compartilhar</a:t>
+            </a:r>
+          </a:p>
+          <a:p>
+            <a:r>
+              <a:t>+13</a:t>
+            </a:r>
+          </a:p>
+          <a:p>
+            <a:r>
+              <a:t>Só 4 pessoas se avaliaram acima do que demonstraram.</a:t>
+            </a:r>
+          </a:p>
+          <a:p>
+            <a:r>
+              <a:t>Fonte: Caderno de Nivelamento DTS (25 concluídos) · lista de convidados do encontro DTS (33)</a:t>
+            </a:r>
+          </a:p>
+          <a:p>
+            <a:r>
+              <a:t>1/5</a:t>
             </a:r>
           </a:p>
         </p:txBody>
@@ -1588,423 +1186,274 @@
           <a:lstStyle/>
           <a:p>
             <a:r>
-              <a:t>Meta em 90 dias: índice consolidado de 78,6 para 85 (Multiplicação), maturidade agêntica de 52 para 70, conclusão de 76% para 100% e 10 multiplicadores formalizados. Três ondas: Ativar, Aprofundar e Multiplicar, com 6 treinamentos específicos.</a:t>
+              <a:t>Sobre este slide: Maturidade agêntica foi a dimensão mais baixa do caderno (52). Na página 04 do caderno, 72% seguiram o caminho “FLOWS → verificar → adaptar” e só 1 pessoa encadeou Método → Skill → Agente. </a:t>
             </a:r>
           </a:p>
           <a:p/>
           <a:p>
             <a:r>
-              <a:t>— Conteúdo da página —</a:t>
-            </a:r>
-          </a:p>
-          <a:p>
-            <a:r>
-              <a:t>DIGITAL &amp; TECHNOLOGY SERVICES</a:t>
-            </a:r>
-          </a:p>
-          <a:p>
-            <a:r>
-              <a:t>03</a:t>
-            </a:r>
-          </a:p>
-          <a:p>
-            <a:r>
-              <a:t>Para onde vamos</a:t>
-            </a:r>
-          </a:p>
-          <a:p>
-            <a:r>
-              <a:t>Sair de Autonomia para Multiplicação em 90 dias. Menos curso genérico e mais prática no trabalho real, com os 10 multiplicadores à frente.</a:t>
-            </a:r>
-          </a:p>
-          <a:p>
-            <a:r>
-              <a:t>“De usuários de IA para construtores de Skills e agentes.”</a:t>
-            </a:r>
-          </a:p>
-          <a:p>
-            <a:r>
-              <a:t>HORIZONTE · NOV 2026 → JAN 2027</a:t>
-            </a:r>
-          </a:p>
-          <a:p>
-            <a:r>
-              <a:t>A META · 90 DIAS</a:t>
-            </a:r>
-          </a:p>
-          <a:p>
-            <a:r>
-              <a:t>ÍNDICE CONSOLIDADO</a:t>
-            </a:r>
-          </a:p>
-          <a:p>
-            <a:r>
-              <a:t>78,6</a:t>
-            </a:r>
-          </a:p>
-          <a:p>
-            <a:r>
-              <a:t>→</a:t>
-            </a:r>
-          </a:p>
-          <a:p>
-            <a:r>
-              <a:t>85</a:t>
-            </a:r>
-          </a:p>
-          <a:p>
-            <a:r>
-              <a:t>faixa Multiplicação na média do time</a:t>
-            </a:r>
-          </a:p>
-          <a:p>
-            <a:r>
-              <a:t>MATURIDADE AGÊNTICA</a:t>
-            </a:r>
-          </a:p>
-          <a:p>
-            <a:r>
-              <a:t>52</a:t>
-            </a:r>
-          </a:p>
-          <a:p>
-            <a:r>
-              <a:t>→</a:t>
-            </a:r>
-          </a:p>
-          <a:p>
-            <a:r>
-              <a:t>70</a:t>
-            </a:r>
-          </a:p>
-          <a:p>
-            <a:r>
-              <a:t>o gargalo vira competência</a:t>
-            </a:r>
-          </a:p>
-          <a:p>
-            <a:r>
-              <a:t>ADOÇÃO DO CADERNO</a:t>
-            </a:r>
-          </a:p>
-          <a:p>
-            <a:r>
-              <a:t>76%</a:t>
-            </a:r>
-          </a:p>
-          <a:p>
-            <a:r>
-              <a:t>→</a:t>
-            </a:r>
-          </a:p>
-          <a:p>
-            <a:r>
-              <a:t>100%</a:t>
-            </a:r>
-          </a:p>
-          <a:p>
-            <a:r>
-              <a:t>8 pessoas a ativar + nova rodada em jan</a:t>
-            </a:r>
-          </a:p>
-          <a:p>
-            <a:r>
-              <a:t>SKILLS PUBLICADAS NO FLOWS</a:t>
-            </a:r>
-          </a:p>
-          <a:p>
-            <a:r>
-              <a:t>—</a:t>
-            </a:r>
-          </a:p>
-          <a:p>
-            <a:r>
-              <a:t>→</a:t>
-            </a:r>
-          </a:p>
-          <a:p>
-            <a:r>
-              <a:t>20</a:t>
-            </a:r>
-          </a:p>
-          <a:p>
-            <a:r>
-              <a:t>2 por multiplicador, reutilizáveis pelo time</a:t>
-            </a:r>
-          </a:p>
-          <a:p>
-            <a:r>
-              <a:t>POR ONDE SEGUIMOS · 3 ONDAS</a:t>
-            </a:r>
-          </a:p>
-          <a:p>
-            <a:r>
-              <a:t>1 · Ativar</a:t>
-            </a:r>
-          </a:p>
-          <a:p>
-            <a:r>
-              <a:t>SEMANAS 1–3</a:t>
-            </a:r>
-          </a:p>
-          <a:p>
-            <a:r>
-              <a:t>Fechar a adoção: convite 1:1 para quem não abriu ou parou no meio</a:t>
-            </a:r>
-          </a:p>
-          <a:p>
-            <a:r>
-              <a:t>Devolutiva individual: cada pessoa recebe seu índice e sua trilha</a:t>
-            </a:r>
-          </a:p>
-          <a:p>
-            <a:r>
-              <a:t>Formalizar os 10 Multiplicadores (faixa ≥ 81) como guilda</a:t>
-            </a:r>
-          </a:p>
-          <a:p>
-            <a:r>
-              <a:t>2 · Aprofundar</a:t>
-            </a:r>
-          </a:p>
-          <a:p>
-            <a:r>
-              <a:t>SEMANAS 4–8</a:t>
-            </a:r>
-          </a:p>
-          <a:p>
-            <a:r>
-              <a:t>Trilhas por faixa (abaixo), com 1 caso real de projeto por pessoa</a:t>
-            </a:r>
-          </a:p>
-          <a:p>
-            <a:r>
-              <a:t>“Clínica de Prompt” quinzenal com feedback ao vivo (o +24 pts)</a:t>
-            </a:r>
-          </a:p>
-          <a:p>
-            <a:r>
-              <a:t>Sprint agêntica: 1 agente/MCP por frente de DTS</a:t>
-            </a:r>
-          </a:p>
-          <a:p>
-            <a:r>
-              <a:t>3 · Multiplicar</a:t>
-            </a:r>
-          </a:p>
-          <a:p>
-            <a:r>
-              <a:t>SEMANAS 9–12</a:t>
-            </a:r>
-          </a:p>
-          <a:p>
-            <a:r>
-              <a:t>Skill da Semana: publicar e demonstrar no FLOWS</a:t>
-            </a:r>
-          </a:p>
-          <a:p>
-            <a:r>
-              <a:t>Ranking gamificado: reuso de Skills e Métodos no time</a:t>
-            </a:r>
-          </a:p>
-          <a:p>
-            <a:r>
-              <a:t>Nova rodada do caderno para medir a evolução</a:t>
-            </a:r>
-          </a:p>
-          <a:p>
-            <a:r>
-              <a:t>TREINAMENTOS ESPECÍFICOS DE IA E FERRAMENTAS</a:t>
-            </a:r>
-          </a:p>
-          <a:p>
-            <a:r>
-              <a:t>Métodos na Prática</a:t>
-            </a:r>
-          </a:p>
-          <a:p>
-            <a:r>
-              <a:t>Do “arquivo antigo” ao Método do FLOWS: achar, adaptar e registrar.</a:t>
-            </a:r>
-          </a:p>
-          <a:p>
-            <a:r>
-              <a:t>EVOLUÇÃO → AUTONOMIA</a:t>
-            </a:r>
-          </a:p>
-          <a:p>
-            <a:r>
-              <a:t>FLOWS</a:t>
-            </a:r>
-          </a:p>
-          <a:p>
-            <a:r>
-              <a:t>2H</a:t>
-            </a:r>
-          </a:p>
-          <a:p>
-            <a:r>
-              <a:t>Prompt de Contexto</a:t>
-            </a:r>
-          </a:p>
-          <a:p>
-            <a:r>
-              <a:t>Objetivo, contexto, público, formato e referências. Clínica com casos reais.</a:t>
-            </a:r>
-          </a:p>
-          <a:p>
-            <a:r>
-              <a:t>TODOS</a:t>
-            </a:r>
-          </a:p>
-          <a:p>
-            <a:r>
-              <a:t>CLAUDE</a:t>
-            </a:r>
-          </a:p>
-          <a:p>
-            <a:r>
-              <a:t>1H30</a:t>
-            </a:r>
-          </a:p>
-          <a:p>
-            <a:r>
-              <a:t>Claude Desktop Power User</a:t>
-            </a:r>
-          </a:p>
-          <a:p>
-            <a:r>
-              <a:t>Projects, Artifacts, arquivos, conectores e memória no dia a dia.</a:t>
-            </a:r>
-          </a:p>
-          <a:p>
-            <a:r>
-              <a:t>EVOLUÇÃO → AUTONOMIA</a:t>
-            </a:r>
-          </a:p>
-          <a:p>
-            <a:r>
-              <a:t>CLAUDE</a:t>
-            </a:r>
-          </a:p>
-          <a:p>
-            <a:r>
-              <a:t>2H</a:t>
-            </a:r>
-          </a:p>
-          <a:p>
-            <a:r>
-              <a:t>Skill Lab</a:t>
-            </a:r>
-          </a:p>
-          <a:p>
-            <a:r>
-              <a:t>Construir, testar e publicar uma Skill autoral reutilizável pelo time.</a:t>
-            </a:r>
-          </a:p>
-          <a:p>
-            <a:r>
-              <a:t>AUTONOMIA</a:t>
-            </a:r>
-          </a:p>
-          <a:p>
-            <a:r>
-              <a:t>SKILLS</a:t>
-            </a:r>
-          </a:p>
-          <a:p>
-            <a:r>
-              <a:t>3H</a:t>
-            </a:r>
-          </a:p>
-          <a:p>
-            <a:r>
-              <a:t>Agentes &amp; MCP</a:t>
-            </a:r>
-          </a:p>
-          <a:p>
-            <a:r>
-              <a:t>Do prompt à orquestração: Método → Skill → Agente, com MCP e dados.</a:t>
-            </a:r>
-          </a:p>
-          <a:p>
-            <a:r>
-              <a:t>GARGALO</a:t>
-            </a:r>
-          </a:p>
-          <a:p>
-            <a:r>
-              <a:t>AGENTES</a:t>
-            </a:r>
-          </a:p>
-          <a:p>
-            <a:r>
-              <a:t>4H</a:t>
-            </a:r>
-          </a:p>
-          <a:p>
-            <a:r>
-              <a:t>Escola de Multiplicadores</a:t>
-            </a:r>
-          </a:p>
-          <a:p>
-            <a:r>
-              <a:t>Facilitação, mentoria e como transformar entrega em ativo do time.</a:t>
-            </a:r>
-          </a:p>
-          <a:p>
-            <a:r>
-              <a:t>MULTIPLICAÇÃO</a:t>
-            </a:r>
-          </a:p>
-          <a:p>
-            <a:r>
-              <a:t>GUILDA</a:t>
-            </a:r>
-          </a:p>
-          <a:p>
-            <a:r>
-              <a:t>2H</a:t>
-            </a:r>
-          </a:p>
-          <a:p>
-            <a:r>
-              <a:t>QUEM FAZ O QUÊ · TRILHA POR FAIXA</a:t>
-            </a:r>
-          </a:p>
-          <a:p>
-            <a:r>
-              <a:t>EVOLUÇÃO · 1 PESSOA</a:t>
-            </a:r>
-          </a:p>
-          <a:p>
-            <a:r>
-              <a:t>Trilha 01 → 02 → 03 + padrinho multiplicador. Foco: hábito de Métodos e FLOWS.</a:t>
-            </a:r>
-          </a:p>
-          <a:p>
-            <a:r>
-              <a:t>AUTONOMIA · 14 PESSOAS</a:t>
-            </a:r>
-          </a:p>
-          <a:p>
-            <a:r>
-              <a:t>Trilha 02 → 04 → 05. Entrega: 1 Skill autoral e 1 agente aplicado a um projeto real.</a:t>
-            </a:r>
-          </a:p>
-          <a:p>
-            <a:r>
-              <a:t>MULTIPLICAÇÃO · 10 PESSOAS</a:t>
-            </a:r>
-          </a:p>
-          <a:p>
-            <a:r>
-              <a:t>Trilha 05 → 06. Cada um apadrinha 2 colegas e publica 2 Skills no FLOWS.</a:t>
-            </a:r>
-          </a:p>
-          <a:p>
-            <a:r>
-              <a:t>Regra de ouro: todo treinamento termina com um ativo publicado no FLOWS, não com um certificado.</a:t>
+              <a:t>O exemplo do status report é ilustrativo e pode ser trocado por qualquer entrega recorrente do seu projeto.</a:t>
+            </a:r>
+          </a:p>
+          <a:p/>
+          <a:p>
+            <a:r>
+              <a:t>— Conteúdo —</a:t>
+            </a:r>
+          </a:p>
+          <a:p>
+            <a:r>
+              <a:t>ALVAREZ &amp; MARSAL</a:t>
+            </a:r>
+          </a:p>
+          <a:p>
+            <a:r>
+              <a:t>DTS · NIVELAMENTO IA</a:t>
+            </a:r>
+          </a:p>
+          <a:p>
+            <a:r>
+              <a:t>DO PEDIDO À DELEGAÇÃO</a:t>
+            </a:r>
+          </a:p>
+          <a:p>
+            <a:r>
+              <a:t>Parte 2 · O que falta para o próximo degrau</a:t>
+            </a:r>
+          </a:p>
+          <a:p>
+            <a:r>
+              <a:t>Diagnóstico IA · DTS</a:t>
+            </a:r>
+          </a:p>
+          <a:p>
+            <a:r>
+              <a:t>2/5</a:t>
+            </a:r>
+          </a:p>
+          <a:p>
+            <a:r>
+              <a:t>SABEMOS PEDIR · AINDA NÃO SABEMOS DELEGAR</a:t>
+            </a:r>
+          </a:p>
+          <a:p>
+            <a:r>
+              <a:t>Maturidade agêntica: 52 · a dimensão mais baixa do caderno</a:t>
+            </a:r>
+          </a:p>
+          <a:p>
+            <a:r>
+              <a:t>🗨️ Pedir</a:t>
+            </a:r>
+          </a:p>
+          <a:p>
+            <a:r>
+              <a:t>COMO FAZEMOS HOJE</a:t>
+            </a:r>
+          </a:p>
+          <a:p>
+            <a:r>
+              <a:t>Uma pergunta por vez. A IA responde e você faz todo o resto: copia, cola, formata e confere.</a:t>
+            </a:r>
+          </a:p>
+          <a:p>
+            <a:r>
+              <a:t>Toda semana começa do zero, com o mesmo pedido escrito de um jeito diferente.</a:t>
+            </a:r>
+          </a:p>
+          <a:p>
+            <a:r>
+              <a:t>O conhecimento fica na sua cabeça (ou no seu chat), não no time.</a:t>
+            </a:r>
+          </a:p>
+          <a:p>
+            <a:r>
+              <a:t>🤝 Delegar</a:t>
+            </a:r>
+          </a:p>
+          <a:p>
+            <a:r>
+              <a:t>PARA ONDE VAMOS</a:t>
+            </a:r>
+          </a:p>
+          <a:p>
+            <a:r>
+              <a:t>Você entrega objetivo, contexto, regras e critério de pronto. O agente executa várias etapas sozinho.</a:t>
+            </a:r>
+          </a:p>
+          <a:p>
+            <a:r>
+              <a:t>Ele usa um Método (o como) e Skills (o padrão A&amp;M) que já existem no FLOWS.</a:t>
+            </a:r>
+          </a:p>
+          <a:p>
+            <a:r>
+              <a:t>Você deixa de digitar e passa a revisar e aprovar.</a:t>
+            </a:r>
+          </a:p>
+          <a:p>
+            <a:r>
+              <a:t>Exemplo · status report semanal do projeto de 2h toda sexta para 15 minutos de revisão</a:t>
+            </a:r>
+          </a:p>
+          <a:p>
+            <a:r>
+              <a:t>1 · MÉTODO (FLOWS)</a:t>
+            </a:r>
+          </a:p>
+          <a:p>
+            <a:r>
+              <a:t>O como</a:t>
+            </a:r>
+          </a:p>
+          <a:p>
+            <a:r>
+              <a:t>O passo a passo DTS para o status report: fontes, seções, régua de semáforo e quem aprova.</a:t>
+            </a:r>
+          </a:p>
+          <a:p>
+            <a:r>
+              <a:t>FLOWS › PMO › Status Report Semanal</a:t>
+            </a:r>
+          </a:p>
+          <a:p>
+            <a:r>
+              <a:t>2 · SKILL</a:t>
+            </a:r>
+          </a:p>
+          <a:p>
+            <a:r>
+              <a:t>O padrão</a:t>
+            </a:r>
+          </a:p>
+          <a:p>
+            <a:r>
+              <a:t>Template A&amp;M, tom executivo e regras como “risco vermelho sempre com plano de ação”.</a:t>
+            </a:r>
+          </a:p>
+          <a:p>
+            <a:r>
+              <a:t>skill: status-report-am</a:t>
+            </a:r>
+          </a:p>
+          <a:p>
+            <a:r>
+              <a:t>3 · AGENTE</a:t>
+            </a:r>
+          </a:p>
+          <a:p>
+            <a:r>
+              <a:t>A delegação</a:t>
+            </a:r>
+          </a:p>
+          <a:p>
+            <a:r>
+              <a:t>“Toda sexta, leia as atas da semana e a planilha de riscos, gere o status no padrão e me mostre antes de enviar.”</a:t>
+            </a:r>
+          </a:p>
+          <a:p>
+            <a:r>
+              <a:t>atas + riscos → rascunho pronto</a:t>
+            </a:r>
+          </a:p>
+          <a:p>
+            <a:r>
+              <a:t>4 · VOCÊ</a:t>
+            </a:r>
+          </a:p>
+          <a:p>
+            <a:r>
+              <a:t>Revisa e aprova</a:t>
+            </a:r>
+          </a:p>
+          <a:p>
+            <a:r>
+              <a:t>Ajusta o que precisa de julgamento: mensagem para o cliente, prioridades e riscos sensíveis.</a:t>
+            </a:r>
+          </a:p>
+          <a:p>
+            <a:r>
+              <a:t>15 min · e não 2h</a:t>
+            </a:r>
+          </a:p>
+          <a:p>
+            <a:r>
+              <a:t>POR QUE USAR MÉTODOS?</a:t>
+            </a:r>
+          </a:p>
+          <a:p>
+            <a:r>
+              <a:t>13 de 25 pessoas usam pouco ou nada (o item de menor uso do caderno)</a:t>
+            </a:r>
+          </a:p>
+          <a:p>
+            <a:r>
+              <a:t>Não reinventa a roda</a:t>
+            </a:r>
+          </a:p>
+          <a:p>
+            <a:r>
+              <a:t>Alguém de DTS já resolveu esse problema. O Método do FLOWS é o atalho para começar do melhor ponto.</a:t>
+            </a:r>
+          </a:p>
+          <a:p>
+            <a:r>
+              <a:t>Qualidade padrão A&amp;M</a:t>
+            </a:r>
+          </a:p>
+          <a:p>
+            <a:r>
+              <a:t>Mesma estrutura, mesmos critérios e a mesma régua em todo projeto, seja quem for o consultor.</a:t>
+            </a:r>
+          </a:p>
+          <a:p>
+            <a:r>
+              <a:t>Sem Método, sem agente</a:t>
+            </a:r>
+          </a:p>
+          <a:p>
+            <a:r>
+              <a:t>Não dá para delegar o que não está escrito. O Método é o manual que o agente segue.</a:t>
+            </a:r>
+          </a:p>
+          <a:p>
+            <a:r>
+              <a:t>Onboarding em horas</a:t>
+            </a:r>
+          </a:p>
+          <a:p>
+            <a:r>
+              <a:t>Quem chega no projeto aprende o jeito DTS lendo o Método, e não perguntando para cada pessoa.</a:t>
+            </a:r>
+          </a:p>
+          <a:p>
+            <a:r>
+              <a:t>Comece amanhã →</a:t>
+            </a:r>
+          </a:p>
+          <a:p>
+            <a:r>
+              <a:t>01 Escolha 1 entrega que se repete toda semana</a:t>
+            </a:r>
+          </a:p>
+          <a:p>
+            <a:r>
+              <a:t>02 Procure o Método dela no FLOWS (ou crie o rascunho)</a:t>
+            </a:r>
+          </a:p>
+          <a:p>
+            <a:r>
+              <a:t>03 Escreva a delegação com as 5 peças do prompt</a:t>
+            </a:r>
+          </a:p>
+          <a:p>
+            <a:r>
+              <a:t>Fonte: Caderno DTS · página 04 (caminho de trabalho) e dimensão de maturidade agêntica · exemplo ilustrativo</a:t>
+            </a:r>
+          </a:p>
+          <a:p>
+            <a:r>
+              <a:t>2/5</a:t>
             </a:r>
           </a:p>
         </p:txBody>
@@ -2074,48 +1523,64 @@
           <a:lstStyle/>
           <a:p>
             <a:r>
-              <a:t>Trilha gratuita no YouTube, em português, em 3 níveis. Os links abrem buscas em PT-BR em canais educativos conhecidos. O botão de vídeo aleatório sugere conteúdo de design, sistemas, jogos e dados.</a:t>
+              <a:t>Sobre este slide: Prompt: na página 07 do caderno, as 17 pessoas que reescreveram o prompt subiram a estrutura de 63 para 87 pontos. Faltavam principalmente contexto e resultado esperado. </a:t>
             </a:r>
           </a:p>
           <a:p/>
           <a:p>
             <a:r>
-              <a:t>— Conteúdo da página —</a:t>
-            </a:r>
-          </a:p>
-          <a:p>
-            <a:r>
-              <a:t>BÔNUS · CATEQUIZAÇÃO EXTERNA</a:t>
-            </a:r>
-          </a:p>
-          <a:p>
-            <a:r>
-              <a:t>04</a:t>
-            </a:r>
-          </a:p>
-          <a:p>
-            <a:r>
-              <a:t>Trilha aberta no YouTube</a:t>
-            </a:r>
-          </a:p>
-          <a:p>
-            <a:r>
-              <a:t>Conteúdo gratuito e em português para estudar no próprio ritmo, do básico ao intermediário. Cada link abre uma busca no YouTube em canais educativos de confiança.</a:t>
-            </a:r>
-          </a:p>
-          <a:p>
-            <a:r>
-              <a:t>“10 minutos por dia &gt; 1 curso por ano.”</a:t>
-            </a:r>
-          </a:p>
-          <a:p>
-            <a:r>
-              <a:t>CURADORIA · CONTEÚDO PÚBLICO E GRATUITO · PT-BR</a:t>
-            </a:r>
-          </a:p>
-          <a:p>
-            <a:r>
-              <a:t>3 NÍVEIS · DO ZERO AO AGENTE</a:t>
+              <a:t>Modelos: esta é a linha de outubro de 2026. Os nomes mudam rápido. No ChatGPT, escolha pelo modo no seletor (Instant, Thinking ou Pro). Dados de cliente só nas ferramentas homologadas pela A&amp;M.</a:t>
+            </a:r>
+          </a:p>
+          <a:p/>
+          <a:p>
+            <a:r>
+              <a:t>— Conteúdo —</a:t>
+            </a:r>
+          </a:p>
+          <a:p>
+            <a:r>
+              <a:t>ALVAREZ &amp; MARSAL</a:t>
+            </a:r>
+          </a:p>
+          <a:p>
+            <a:r>
+              <a:t>DTS · NIVELAMENTO IA</a:t>
+            </a:r>
+          </a:p>
+          <a:p>
+            <a:r>
+              <a:t>PROMPT CERTO, MODELO CERTO</a:t>
+            </a:r>
+          </a:p>
+          <a:p>
+            <a:r>
+              <a:t>Parte 2 · Como pedir melhor e com qual IA</a:t>
+            </a:r>
+          </a:p>
+          <a:p>
+            <a:r>
+              <a:t>Diagnóstico IA · DTS</a:t>
+            </a:r>
+          </a:p>
+          <a:p>
+            <a:r>
+              <a:t>3/5</a:t>
+            </a:r>
+          </a:p>
+          <a:p>
+            <a:r>
+              <a:t>COMO MELHORAR OS PROMPTS · E QUAL IA USAR PARA CADA TRABALHO</a:t>
+            </a:r>
+          </a:p>
+          <a:p>
+            <a:r>
+              <a:t>Quem reescreveu o prompt no caderno subiu de 63 para 87 pontos</a:t>
+            </a:r>
+          </a:p>
+          <a:p>
+            <a:r>
+              <a:t>AS 5 PEÇAS DE UM BOM PROMPT</a:t>
             </a:r>
           </a:p>
           <a:p>
@@ -2125,57 +1590,12 @@
           </a:p>
           <a:p>
             <a:r>
-              <a:t>Nível 1 · Básico</a:t>
-            </a:r>
-          </a:p>
-          <a:p>
-            <a:r>
-              <a:t>Entender e começar a usar</a:t>
-            </a:r>
-          </a:p>
-          <a:p>
-            <a:r>
-              <a:t>O que é IA generativa, explicado sem jargão</a:t>
-            </a:r>
-          </a:p>
-          <a:p>
-            <a:r>
-              <a:t>Canal Nerdologia · busca</a:t>
-            </a:r>
-          </a:p>
-          <a:p>
-            <a:r>
-              <a:t>Como escrever bons prompts</a:t>
-            </a:r>
-          </a:p>
-          <a:p>
-            <a:r>
-              <a:t>Hashtag Treinamentos · busca</a:t>
-            </a:r>
-          </a:p>
-          <a:p>
-            <a:r>
-              <a:t>Claude: primeiros passos em português</a:t>
-            </a:r>
-          </a:p>
-          <a:p>
-            <a:r>
-              <a:t>tutoriais PT-BR · busca</a:t>
-            </a:r>
-          </a:p>
-          <a:p>
-            <a:r>
-              <a:t>IA para produtividade no trabalho</a:t>
-            </a:r>
-          </a:p>
-          <a:p>
-            <a:r>
-              <a:t>Sebrae · busca</a:t>
-            </a:r>
-          </a:p>
-          <a:p>
-            <a:r>
-              <a:t>Desafio prático: refaça um pedido da sua semana usando objetivo + contexto + formato e compare os resultados.</a:t>
+              <a:t>Objetivo</a:t>
+            </a:r>
+          </a:p>
+          <a:p>
+            <a:r>
+              <a:t>o que você quer e para quê</a:t>
             </a:r>
           </a:p>
           <a:p>
@@ -2185,57 +1605,12 @@
           </a:p>
           <a:p>
             <a:r>
-              <a:t>Nível 2 · Intermediário</a:t>
-            </a:r>
-          </a:p>
-          <a:p>
-            <a:r>
-              <a:t>Contexto, reuso e automação</a:t>
-            </a:r>
-          </a:p>
-          <a:p>
-            <a:r>
-              <a:t>Engenharia de prompt: técnicas e exemplos</a:t>
-            </a:r>
-          </a:p>
-          <a:p>
-            <a:r>
-              <a:t>Filipe Deschamps · busca</a:t>
-            </a:r>
-          </a:p>
-          <a:p>
-            <a:r>
-              <a:t>Claude Projects e Artifacts na prática</a:t>
-            </a:r>
-          </a:p>
-          <a:p>
-            <a:r>
-              <a:t>tutoriais PT-BR · busca</a:t>
-            </a:r>
-          </a:p>
-          <a:p>
-            <a:r>
-              <a:t>RAG explicado: IA com seus documentos</a:t>
-            </a:r>
-          </a:p>
-          <a:p>
-            <a:r>
-              <a:t>Código Fonte TV · busca</a:t>
-            </a:r>
-          </a:p>
-          <a:p>
-            <a:r>
-              <a:t>Automação com IA e n8n do zero</a:t>
-            </a:r>
-          </a:p>
-          <a:p>
-            <a:r>
-              <a:t>tutoriais PT-BR · busca</a:t>
-            </a:r>
-          </a:p>
-          <a:p>
-            <a:r>
-              <a:t>Desafio prático: transforme uma entrega recorrente em um Projeto do Claude com instruções e arquivos de referência.</a:t>
+              <a:t>Contexto</a:t>
+            </a:r>
+          </a:p>
+          <a:p>
+            <a:r>
+              <a:t>cliente, projeto, momento, restrições</a:t>
             </a:r>
           </a:p>
           <a:p>
@@ -2245,97 +1620,322 @@
           </a:p>
           <a:p>
             <a:r>
-              <a:t>Nível 3 · Agentes</a:t>
-            </a:r>
-          </a:p>
-          <a:p>
-            <a:r>
-              <a:t>Orquestrar Método → Skill → Agente</a:t>
-            </a:r>
-          </a:p>
-          <a:p>
-            <a:r>
-              <a:t>Agentes de IA: o que são e como funcionam</a:t>
-            </a:r>
-          </a:p>
-          <a:p>
-            <a:r>
-              <a:t>Código Fonte TV · busca</a:t>
-            </a:r>
-          </a:p>
-          <a:p>
-            <a:r>
-              <a:t>MCP (Model Context Protocol) explicado</a:t>
-            </a:r>
-          </a:p>
-          <a:p>
-            <a:r>
-              <a:t>tutoriais PT-BR · busca</a:t>
-            </a:r>
-          </a:p>
-          <a:p>
-            <a:r>
-              <a:t>Claude Code na prática</a:t>
-            </a:r>
-          </a:p>
-          <a:p>
-            <a:r>
-              <a:t>tutoriais PT-BR · busca</a:t>
-            </a:r>
-          </a:p>
-          <a:p>
-            <a:r>
-              <a:t>Sistemas multiagentes com CrewAI</a:t>
-            </a:r>
-          </a:p>
-          <a:p>
-            <a:r>
-              <a:t>DIO · busca</a:t>
-            </a:r>
-          </a:p>
-          <a:p>
-            <a:r>
-              <a:t>Desafio prático: desenhe no papel um agente Método → Skill → Agente para uma tarefa do seu projeto e leve à Clínica.</a:t>
-            </a:r>
-          </a:p>
-          <a:p>
-            <a:r>
-              <a:t>Vídeo aleatório</a:t>
-            </a:r>
-          </a:p>
-          <a:p>
-            <a:r>
-              <a:t>DESIGN</a:t>
-            </a:r>
-          </a:p>
-          <a:p>
-            <a:r>
-              <a:t>SISTEMAS</a:t>
-            </a:r>
-          </a:p>
-          <a:p>
-            <a:r>
-              <a:t>JOGOS</a:t>
-            </a:r>
-          </a:p>
-          <a:p>
-            <a:r>
-              <a:t>DADOS</a:t>
-            </a:r>
-          </a:p>
-          <a:p>
-            <a:r>
-              <a:t>PRODUTIVIDADE</a:t>
-            </a:r>
-          </a:p>
-          <a:p>
-            <a:r>
-              <a:t>▶ Aela UX UI design</a:t>
-            </a:r>
-          </a:p>
-          <a:p>
-            <a:r>
-              <a:t>Categoria: Design · abre a busca no YouTube</a:t>
+              <a:t>Público</a:t>
+            </a:r>
+          </a:p>
+          <a:p>
+            <a:r>
+              <a:t>quem vai ler (C-level, time, cliente)</a:t>
+            </a:r>
+          </a:p>
+          <a:p>
+            <a:r>
+              <a:t>4</a:t>
+            </a:r>
+          </a:p>
+          <a:p>
+            <a:r>
+              <a:t>Formato</a:t>
+            </a:r>
+          </a:p>
+          <a:p>
+            <a:r>
+              <a:t>tamanho, estrutura, tom, entregável</a:t>
+            </a:r>
+          </a:p>
+          <a:p>
+            <a:r>
+              <a:t>5</a:t>
+            </a:r>
+          </a:p>
+          <a:p>
+            <a:r>
+              <a:t>Referências</a:t>
+            </a:r>
+          </a:p>
+          <a:p>
+            <a:r>
+              <a:t>exemplos, template, Método do FLOWS</a:t>
+            </a:r>
+          </a:p>
+          <a:p>
+            <a:r>
+              <a:t>✗ PEDIDO</a:t>
+            </a:r>
+          </a:p>
+          <a:p>
+            <a:r>
+              <a:t>“Faz um resumo dessa reunião.”</a:t>
+            </a:r>
+          </a:p>
+          <a:p>
+            <a:r>
+              <a:t>✓ DELEGAÇÃO</a:t>
+            </a:r>
+          </a:p>
+          <a:p>
+            <a:r>
+              <a:t>“Resuma a ata em anexo para o sponsor do cliente (público), destacando decisões e riscos (objetivo), em 5 bullets (formato), no padrão do Método Ata DTS (referência).”</a:t>
+            </a:r>
+          </a:p>
+          <a:p>
+            <a:r>
+              <a:t>CHECKLIST ANTES DE ENVIAR</a:t>
+            </a:r>
+          </a:p>
+          <a:p>
+            <a:r>
+              <a:t>☐ Disse para quem é e para que serve?</a:t>
+            </a:r>
+          </a:p>
+          <a:p>
+            <a:r>
+              <a:t>☐ Deu um exemplo ou o Método de referência?</a:t>
+            </a:r>
+          </a:p>
+          <a:p>
+            <a:r>
+              <a:t>☐ Disse como saber que ficou pronto (formato, tamanho, critério)?</a:t>
+            </a:r>
+          </a:p>
+          <a:p>
+            <a:r>
+              <a:t>Dica: termine pedindo “antes de responder, me faça as perguntas que faltam”.</a:t>
+            </a:r>
+          </a:p>
+          <a:p>
+            <a:r>
+              <a:t>QUAL IA PARA QUAL TRABALHO</a:t>
+            </a:r>
+          </a:p>
+          <a:p>
+            <a:r>
+              <a:t>LINHA DE OUT/2026</a:t>
+            </a:r>
+          </a:p>
+          <a:p>
+            <a:r>
+              <a:t>FRENTE DE TRABALHO	CLAUDE	CHATGPT</a:t>
+            </a:r>
+          </a:p>
+          <a:p>
+            <a:r>
+              <a:t>🧠</a:t>
+            </a:r>
+          </a:p>
+          <a:p>
+            <a:r>
+              <a:t>Pensar</a:t>
+            </a:r>
+          </a:p>
+          <a:p>
+            <a:r>
+              <a:t>estratégia, diagnóstico, decisões difíceis</a:t>
+            </a:r>
+          </a:p>
+          <a:p>
+            <a:r>
+              <a:t>	Opus 5.5</a:t>
+            </a:r>
+          </a:p>
+          <a:p>
+            <a:r>
+              <a:t>Fable 5.1 para o problema mais difícil</a:t>
+            </a:r>
+          </a:p>
+          <a:p>
+            <a:r>
+              <a:t>	Thinking</a:t>
+            </a:r>
+          </a:p>
+          <a:p>
+            <a:r>
+              <a:t>Pro para análise crítica de alto risco</a:t>
+            </a:r>
+          </a:p>
+          <a:p>
+            <a:r>
+              <a:t>✍️</a:t>
+            </a:r>
+          </a:p>
+          <a:p>
+            <a:r>
+              <a:t>Criar</a:t>
+            </a:r>
+          </a:p>
+          <a:p>
+            <a:r>
+              <a:t>textos, decks, narrativa, propostas</a:t>
+            </a:r>
+          </a:p>
+          <a:p>
+            <a:r>
+              <a:t>	Sonnet 5.5</a:t>
+            </a:r>
+          </a:p>
+          <a:p>
+            <a:r>
+              <a:t>com Artifacts para páginas e apresentações</a:t>
+            </a:r>
+          </a:p>
+          <a:p>
+            <a:r>
+              <a:t>	Instant + imagens</a:t>
+            </a:r>
+          </a:p>
+          <a:p>
+            <a:r>
+              <a:t>geração de imagem nativa no chat</a:t>
+            </a:r>
+          </a:p>
+          <a:p>
+            <a:r>
+              <a:t>🔎</a:t>
+            </a:r>
+          </a:p>
+          <a:p>
+            <a:r>
+              <a:t>Pesquisar</a:t>
+            </a:r>
+          </a:p>
+          <a:p>
+            <a:r>
+              <a:t>mercado, benchmark, fontes</a:t>
+            </a:r>
+          </a:p>
+          <a:p>
+            <a:r>
+              <a:t>	Research</a:t>
+            </a:r>
+          </a:p>
+          <a:p>
+            <a:r>
+              <a:t>pesquisa com fontes citadas</a:t>
+            </a:r>
+          </a:p>
+          <a:p>
+            <a:r>
+              <a:t>	Deep Research</a:t>
+            </a:r>
+          </a:p>
+          <a:p>
+            <a:r>
+              <a:t>relatório longo com fontes</a:t>
+            </a:r>
+          </a:p>
+          <a:p>
+            <a:r>
+              <a:t>💻</a:t>
+            </a:r>
+          </a:p>
+          <a:p>
+            <a:r>
+              <a:t>Desenvolver</a:t>
+            </a:r>
+          </a:p>
+          <a:p>
+            <a:r>
+              <a:t>código, protótipos, dashboards</a:t>
+            </a:r>
+          </a:p>
+          <a:p>
+            <a:r>
+              <a:t>	Claude Code</a:t>
+            </a:r>
+          </a:p>
+          <a:p>
+            <a:r>
+              <a:t>com Sonnet 5.5 (dia a dia) ou Opus 5.5</a:t>
+            </a:r>
+          </a:p>
+          <a:p>
+            <a:r>
+              <a:t>	Codex</a:t>
+            </a:r>
+          </a:p>
+          <a:p>
+            <a:r>
+              <a:t>agente de código da OpenAI</a:t>
+            </a:r>
+          </a:p>
+          <a:p>
+            <a:r>
+              <a:t>🧩</a:t>
+            </a:r>
+          </a:p>
+          <a:p>
+            <a:r>
+              <a:t>Construir</a:t>
+            </a:r>
+          </a:p>
+          <a:p>
+            <a:r>
+              <a:t>agentes, automações, Skills</a:t>
+            </a:r>
+          </a:p>
+          <a:p>
+            <a:r>
+              <a:t>	Cowork + Skills + MCP</a:t>
+            </a:r>
+          </a:p>
+          <a:p>
+            <a:r>
+              <a:t>delegação de tarefas com ferramentas</a:t>
+            </a:r>
+          </a:p>
+          <a:p>
+            <a:r>
+              <a:t>	Agent + GPTs</a:t>
+            </a:r>
+          </a:p>
+          <a:p>
+            <a:r>
+              <a:t>modo agente e assistentes customizados</a:t>
+            </a:r>
+          </a:p>
+          <a:p>
+            <a:r>
+              <a:t>⚡</a:t>
+            </a:r>
+          </a:p>
+          <a:p>
+            <a:r>
+              <a:t>Velocidade</a:t>
+            </a:r>
+          </a:p>
+          <a:p>
+            <a:r>
+              <a:t>triagem, resumos, volume</a:t>
+            </a:r>
+          </a:p>
+          <a:p>
+            <a:r>
+              <a:t>	Haiku 5.5</a:t>
+            </a:r>
+          </a:p>
+          <a:p>
+            <a:r>
+              <a:t>rápido e barato para tarefas simples</a:t>
+            </a:r>
+          </a:p>
+          <a:p>
+            <a:r>
+              <a:t>	Instant</a:t>
+            </a:r>
+          </a:p>
+          <a:p>
+            <a:r>
+              <a:t>resposta imediata</a:t>
+            </a:r>
+          </a:p>
+          <a:p>
+            <a:r>
+              <a:t>Fonte: Caderno DTS · páginas 06 e 07 · linha de modelos Anthropic e OpenAI em out/2026 (confirme sempre no seletor da ferramenta)</a:t>
+            </a:r>
+          </a:p>
+          <a:p>
+            <a:r>
+              <a:t>3/5</a:t>
             </a:r>
           </a:p>
         </p:txBody>
@@ -2405,43 +2005,616 @@
           <a:lstStyle/>
           <a:p>
             <a:r>
-              <a:t>Página 7 do caderno: retrato falado. 23 pessoas escreveram um prompt e só 14 marcaram quem retrataram. As outras 11 foram identificadas pelas características descritas. Ana Paula foi a mais retratada (5 vezes).</a:t>
+              <a:t>Sobre este slide: Direcionador: três compromissos simples, sem regras novas. </a:t>
             </a:r>
           </a:p>
           <a:p/>
           <a:p>
             <a:r>
-              <a:t>— Conteúdo da página —</a:t>
-            </a:r>
-          </a:p>
-          <a:p>
-            <a:r>
-              <a:t>PÁGINA 07 · RETRATO FALADO DTS</a:t>
-            </a:r>
-          </a:p>
-          <a:p>
-            <a:r>
-              <a:t>05</a:t>
-            </a:r>
-          </a:p>
-          <a:p>
-            <a:r>
-              <a:t>Mural do Retrato Falado</a:t>
-            </a:r>
-          </a:p>
-          <a:p>
-            <a:r>
-              <a:t>23 pessoas escreveram um prompt de caricatura e só 14 marcaram quem era. Fizemos o trabalho de detetive e as outras 11 foram identificadas pelas pistas que cada um deu.</a:t>
-            </a:r>
-          </a:p>
-          <a:p>
-            <a:r>
-              <a:t>“Passe o mouse para descobrir quem desenhou quem.”</a:t>
-            </a:r>
-          </a:p>
-          <a:p>
-            <a:r>
-              <a:t>CARICATURAS GERADAS A PARTIR DOS PROMPTS DO TIME</a:t>
+              <a:t>Trilha de estudos: os vídeos são gratuitos, em português, e foram escolhidos em canais reconhecidos (Akita, Full Cycle, Deborah Folloni, Rodrigo do Carmo, Mário Trentim, Hashtag). Comece pelo nível da sua faixa. </a:t>
+            </a:r>
+          </a:p>
+          <a:p/>
+          <a:p>
+            <a:r>
+              <a:t>Aleatório: sorteia conteúdos de design, sistemas, jogos, dados e automação para ampliar o repertório.</a:t>
+            </a:r>
+          </a:p>
+          <a:p/>
+          <a:p>
+            <a:r>
+              <a:t>— Conteúdo —</a:t>
+            </a:r>
+          </a:p>
+          <a:p>
+            <a:r>
+              <a:t>ALVAREZ &amp; MARSAL</a:t>
+            </a:r>
+          </a:p>
+          <a:p>
+            <a:r>
+              <a:t>DTS · NIVELAMENTO IA</a:t>
+            </a:r>
+          </a:p>
+          <a:p>
+            <a:r>
+              <a:t>PARA ONDE VAMOS</a:t>
+            </a:r>
+          </a:p>
+          <a:p>
+            <a:r>
+              <a:t>Parte 3 · Direcionador e trilha de estudos</a:t>
+            </a:r>
+          </a:p>
+          <a:p>
+            <a:r>
+              <a:t>Diagnóstico IA · DTS</a:t>
+            </a:r>
+          </a:p>
+          <a:p>
+            <a:r>
+              <a:t>4/5</a:t>
+            </a:r>
+          </a:p>
+          <a:p>
+            <a:r>
+              <a:t>DIRECIONADOR · FLOWS E SKILLS NO INÍCIO DE TODO PROJETO</a:t>
+            </a:r>
+          </a:p>
+          <a:p>
+            <a:r>
+              <a:t>Sem regras novas: hábito, estudo e compartilhamento</a:t>
+            </a:r>
+          </a:p>
+          <a:p>
+            <a:r>
+              <a:t>1</a:t>
+            </a:r>
+          </a:p>
+          <a:p>
+            <a:r>
+              <a:t>Todo projeto começa pelo FLOWS</a:t>
+            </a:r>
+          </a:p>
+          <a:p>
+            <a:r>
+              <a:t>No kick-off, antes do primeiro entregável:</a:t>
+            </a:r>
+          </a:p>
+          <a:p>
+            <a:r>
+              <a:t>01 buscar o Método</a:t>
+            </a:r>
+          </a:p>
+          <a:p>
+            <a:r>
+              <a:t>02 ativar as Skills</a:t>
+            </a:r>
+          </a:p>
+          <a:p>
+            <a:r>
+              <a:t>03 adaptar ao cliente</a:t>
+            </a:r>
+          </a:p>
+          <a:p>
+            <a:r>
+              <a:t>04 registrar o que é novo</a:t>
+            </a:r>
+          </a:p>
+          <a:p>
+            <a:r>
+              <a:t>2</a:t>
+            </a:r>
+          </a:p>
+          <a:p>
+            <a:r>
+              <a:t>Cada um estuda no seu nível</a:t>
+            </a:r>
+          </a:p>
+          <a:p>
+            <a:r>
+              <a:t>Evolução → níveis 1 e 2 · Autonomia → níveis 2 e 3 · Multiplicação → níveis 3 e 4. Dois vídeos por mês e uma aplicação no projeto.</a:t>
+            </a:r>
+          </a:p>
+          <a:p>
+            <a:r>
+              <a:t>3</a:t>
+            </a:r>
+          </a:p>
+          <a:p>
+            <a:r>
+              <a:t>O que funcionou vira ativo</a:t>
+            </a:r>
+          </a:p>
+          <a:p>
+            <a:r>
+              <a:t>Um prompt que deu certo vira Skill. Um jeito de fazer que deu certo vira Método no FLOWS. Os 10 multiplicadores ajudam a publicar.</a:t>
+            </a:r>
+          </a:p>
+          <a:p>
+            <a:r>
+              <a:t>1</a:t>
+            </a:r>
+          </a:p>
+          <a:p>
+            <a:r>
+              <a:t>Nível 1 · Compreender</a:t>
+            </a:r>
+          </a:p>
+          <a:p>
+            <a:r>
+              <a:t>Prompt e primeiros passos</a:t>
+            </a:r>
+          </a:p>
+          <a:p>
+            <a:r>
+              <a:t>LUCAS MOREIRA</a:t>
+            </a:r>
+          </a:p>
+          <a:p>
+            <a:r>
+              <a:t>Engenharia de Prompt: o guia completo</a:t>
+            </a:r>
+          </a:p>
+          <a:p>
+            <a:r>
+              <a:t>Prompts consistentes, tokens e versionamento</a:t>
+            </a:r>
+          </a:p>
+          <a:p>
+            <a:r>
+              <a:t>SANDECO</a:t>
+            </a:r>
+          </a:p>
+          <a:p>
+            <a:r>
+              <a:t>Curso ChatGPT: Engenharia de Prompts</a:t>
+            </a:r>
+          </a:p>
+          <a:p>
+            <a:r>
+              <a:t>Formação de prompts e aplicações práticas</a:t>
+            </a:r>
+          </a:p>
+          <a:p>
+            <a:r>
+              <a:t>RODRIGO DO CARMO</a:t>
+            </a:r>
+          </a:p>
+          <a:p>
+            <a:r>
+              <a:t>Claude Cowork: curso completo para iniciantes</a:t>
+            </a:r>
+          </a:p>
+          <a:p>
+            <a:r>
+              <a:t>Skills, MCP e plugins sem programar</a:t>
+            </a:r>
+          </a:p>
+          <a:p>
+            <a:r>
+              <a:t>PROF. MENDES</a:t>
+            </a:r>
+          </a:p>
+          <a:p>
+            <a:r>
+              <a:t>Engenharia de Prompt na prática (aula 01)</a:t>
+            </a:r>
+          </a:p>
+          <a:p>
+            <a:r>
+              <a:t>Exercícios guiados, do zero</a:t>
+            </a:r>
+          </a:p>
+          <a:p>
+            <a:r>
+              <a:t>Use em: atas, e-mails, resumos executivos e primeiras versões de entregáveis.</a:t>
+            </a:r>
+          </a:p>
+          <a:p>
+            <a:r>
+              <a:t>2</a:t>
+            </a:r>
+          </a:p>
+          <a:p>
+            <a:r>
+              <a:t>Nível 2 · Construir</a:t>
+            </a:r>
+          </a:p>
+          <a:p>
+            <a:r>
+              <a:t>Claude Code, Skills e RAG</a:t>
+            </a:r>
+          </a:p>
+          <a:p>
+            <a:r>
+              <a:t>RODRIGO DO CARMO</a:t>
+            </a:r>
+          </a:p>
+          <a:p>
+            <a:r>
+              <a:t>Claude Code: curso completo para iniciantes</a:t>
+            </a:r>
+          </a:p>
+          <a:p>
+            <a:r>
+              <a:t>Contexto, Skills, MCP e subagentes · 1h27</a:t>
+            </a:r>
+          </a:p>
+          <a:p>
+            <a:r>
+              <a:t>DEBORAH FOLLONI</a:t>
+            </a:r>
+          </a:p>
+          <a:p>
+            <a:r>
+              <a:t>Vibe Coding não funciona (novo workflow)</a:t>
+            </a:r>
+          </a:p>
+          <a:p>
+            <a:r>
+              <a:t>Especificar, planejar e dividir tarefas</a:t>
+            </a:r>
+          </a:p>
+          <a:p>
+            <a:r>
+              <a:t>FULL CYCLE</a:t>
+            </a:r>
+          </a:p>
+          <a:p>
+            <a:r>
+              <a:t>Claude Code: guia completo</a:t>
+            </a:r>
+          </a:p>
+          <a:p>
+            <a:r>
+              <a:t>O que todo dev precisa saber</a:t>
+            </a:r>
+          </a:p>
+          <a:p>
+            <a:r>
+              <a:t>DEBORAH FOLLONI</a:t>
+            </a:r>
+          </a:p>
+          <a:p>
+            <a:r>
+              <a:t>Agora eu só uso Skills</a:t>
+            </a:r>
+          </a:p>
+          <a:p>
+            <a:r>
+              <a:t>Por que Skills substituem agentes soltos</a:t>
+            </a:r>
+          </a:p>
+          <a:p>
+            <a:r>
+              <a:t>Use em: transformar entregas recorrentes em Skills e protótipos para o cliente.</a:t>
+            </a:r>
+          </a:p>
+          <a:p>
+            <a:r>
+              <a:t>3</a:t>
+            </a:r>
+          </a:p>
+          <a:p>
+            <a:r>
+              <a:t>Nível 3 · Orquestrar</a:t>
+            </a:r>
+          </a:p>
+          <a:p>
+            <a:r>
+              <a:t>Agentes em produção</a:t>
+            </a:r>
+          </a:p>
+          <a:p>
+            <a:r>
+              <a:t>FABIO AKITA</a:t>
+            </a:r>
+          </a:p>
+          <a:p>
+            <a:r>
+              <a:t>Minha experiência com Agile Vibe Coding</a:t>
+            </a:r>
+          </a:p>
+          <a:p>
+            <a:r>
+              <a:t>37 dias com agentes em produção · 58 min</a:t>
+            </a:r>
+          </a:p>
+          <a:p>
+            <a:r>
+              <a:t>FULL CYCLE</a:t>
+            </a:r>
+          </a:p>
+          <a:p>
+            <a:r>
+              <a:t>Criando agentes de IA com LangChain</a:t>
+            </a:r>
+          </a:p>
+          <a:p>
+            <a:r>
+              <a:t>Chains, ferramentas e agentes ReAct</a:t>
+            </a:r>
+          </a:p>
+          <a:p>
+            <a:r>
+              <a:t>FULL CYCLE</a:t>
+            </a:r>
+          </a:p>
+          <a:p>
+            <a:r>
+              <a:t>Subagentes no Claude Code na prática</a:t>
+            </a:r>
+          </a:p>
+          <a:p>
+            <a:r>
+              <a:t>Raio-X de arquitetura e dependências</a:t>
+            </a:r>
+          </a:p>
+          <a:p>
+            <a:r>
+              <a:t>FULL CYCLE</a:t>
+            </a:r>
+          </a:p>
+          <a:p>
+            <a:r>
+              <a:t>Agentes na prática: analisa logs e abre issues</a:t>
+            </a:r>
+          </a:p>
+          <a:p>
+            <a:r>
+              <a:t>Agente com ferramentas reais</a:t>
+            </a:r>
+          </a:p>
+          <a:p>
+            <a:r>
+              <a:t>Use em: engenharia reversa de sistemas, modernização e agentes internos.</a:t>
+            </a:r>
+          </a:p>
+          <a:p>
+            <a:r>
+              <a:t>4</a:t>
+            </a:r>
+          </a:p>
+          <a:p>
+            <a:r>
+              <a:t>Nível 4 · Consultoria</a:t>
+            </a:r>
+          </a:p>
+          <a:p>
+            <a:r>
+              <a:t>PMO, processos e sistemas</a:t>
+            </a:r>
+          </a:p>
+          <a:p>
+            <a:r>
+              <a:t>MÁRIO TRENTIM</a:t>
+            </a:r>
+          </a:p>
+          <a:p>
+            <a:r>
+              <a:t>Workshop: gestão de projetos usando IA</a:t>
+            </a:r>
+          </a:p>
+          <a:p>
+            <a:r>
+              <a:t>Escopo, riscos e cronograma com IA</a:t>
+            </a:r>
+          </a:p>
+          <a:p>
+            <a:r>
+              <a:t>CURSO EM VÍDEO</a:t>
+            </a:r>
+          </a:p>
+          <a:p>
+            <a:r>
+              <a:t>Planejamento e gestão de projetos com IA</a:t>
+            </a:r>
+          </a:p>
+          <a:p>
+            <a:r>
+              <a:t>PMO operacional apoiado por IA</a:t>
+            </a:r>
+          </a:p>
+          <a:p>
+            <a:r>
+              <a:t>HASHTAG PROGRAMAÇÃO</a:t>
+            </a:r>
+          </a:p>
+          <a:p>
+            <a:r>
+              <a:t>Agente de IA com RAG (LangChain)</a:t>
+            </a:r>
+          </a:p>
+          <a:p>
+            <a:r>
+              <a:t>Consultar contratos e PDFs: base para due diligence</a:t>
+            </a:r>
+          </a:p>
+          <a:p>
+            <a:r>
+              <a:t>AFONSO LOPES</a:t>
+            </a:r>
+          </a:p>
+          <a:p>
+            <a:r>
+              <a:t>Agentes e automação para empresas (canal)</a:t>
+            </a:r>
+          </a:p>
+          <a:p>
+            <a:r>
+              <a:t>Levantamento, proposta e implantação no cliente</a:t>
+            </a:r>
+          </a:p>
+          <a:p>
+            <a:r>
+              <a:t>Use em: PMO, relatórios de status, riscos, processos e diligências.</a:t>
+            </a:r>
+          </a:p>
+          <a:p>
+            <a:r>
+              <a:t>Aleatório</a:t>
+            </a:r>
+          </a:p>
+          <a:p>
+            <a:r>
+              <a:t>DESIGN</a:t>
+            </a:r>
+          </a:p>
+          <a:p>
+            <a:r>
+              <a:t>SISTEMAS</a:t>
+            </a:r>
+          </a:p>
+          <a:p>
+            <a:r>
+              <a:t>JOGOS</a:t>
+            </a:r>
+          </a:p>
+          <a:p>
+            <a:r>
+              <a:t>DADOS</a:t>
+            </a:r>
+          </a:p>
+          <a:p>
+            <a:r>
+              <a:t>AUTOMAÇÃO</a:t>
+            </a:r>
+          </a:p>
+          <a:p>
+            <a:r>
+              <a:t>▶ Curso completo de Figma: UX/UI do básico ao avançado</a:t>
+            </a:r>
+          </a:p>
+          <a:p>
+            <a:r>
+              <a:t>Categoria Design · role de novo para outra sugestão</a:t>
+            </a:r>
+          </a:p>
+          <a:p>
+            <a:r>
+              <a:t>Curadoria: vídeos gratuitos em PT-BR no YouTube · links verificados em out/2026</a:t>
+            </a:r>
+          </a:p>
+          <a:p>
+            <a:r>
+              <a:t>4/5</a:t>
+            </a:r>
+          </a:p>
+        </p:txBody>
+      </p:sp>
+      <p:sp>
+        <p:nvSpPr>
+          <p:cNvPr id="4" name="Slide Number Placeholder 3"/>
+          <p:cNvSpPr>
+            <a:spLocks noGrp="1"/>
+          </p:cNvSpPr>
+          <p:nvPr>
+            <p:ph type="sldNum" idx="5" sz="quarter"/>
+          </p:nvPr>
+        </p:nvSpPr>
+        <p:spPr/>
+      </p:sp>
+    </p:spTree>
+  </p:cSld>
+  <p:clrMapOvr>
+    <a:masterClrMapping/>
+  </p:clrMapOvr>
+</p:notes>
+</file>
+
+<file path=ppt/notesSlides/notesSlide6.xml><?xml version="1.0" encoding="utf-8"?>
+<p:notes xmlns:a="http://schemas.openxmlformats.org/drawingml/2006/main" xmlns:p="http://schemas.openxmlformats.org/presentationml/2006/main" xmlns:r="http://schemas.openxmlformats.org/officeDocument/2006/relationships">
+  <p:cSld>
+    <p:spTree>
+      <p:nvGrpSpPr>
+        <p:cNvPr id="1" name=""/>
+        <p:cNvGrpSpPr/>
+        <p:nvPr/>
+      </p:nvGrpSpPr>
+      <p:grpSpPr>
+        <a:xfrm>
+          <a:off x="0" y="0"/>
+          <a:ext cx="0" cy="0"/>
+          <a:chOff x="0" y="0"/>
+          <a:chExt cx="0" cy="0"/>
+        </a:xfrm>
+      </p:grpSpPr>
+      <p:sp>
+        <p:nvSpPr>
+          <p:cNvPr id="2" name="Slide Image Placeholder 1"/>
+          <p:cNvSpPr>
+            <a:spLocks noGrp="1"/>
+          </p:cNvSpPr>
+          <p:nvPr>
+            <p:ph type="sldImg" idx="2"/>
+          </p:nvPr>
+        </p:nvSpPr>
+        <p:spPr/>
+      </p:sp>
+      <p:sp>
+        <p:nvSpPr>
+          <p:cNvPr id="3" name="Notes Placeholder 2"/>
+          <p:cNvSpPr>
+            <a:spLocks noGrp="1"/>
+          </p:cNvSpPr>
+          <p:nvPr>
+            <p:ph type="body" idx="3" sz="quarter"/>
+          </p:nvPr>
+        </p:nvSpPr>
+        <p:spPr/>
+        <p:txBody>
+          <a:bodyPr/>
+          <a:lstStyle/>
+          <a:p>
+            <a:r>
+              <a:t>Sobre este slide: Página 07 do caderno, o Retrato Falado. 23 pessoas escreveram um prompt de caricatura e só 14 marcaram quem retrataram. As outras 11 foram identificadas pelas características descritas, com indicação de certeza, provável ou palpite. Passe o mouse em cada caricatura para ver quem desenhou.</a:t>
+            </a:r>
+          </a:p>
+          <a:p/>
+          <a:p>
+            <a:r>
+              <a:t>— Conteúdo —</a:t>
+            </a:r>
+          </a:p>
+          <a:p>
+            <a:r>
+              <a:t>ALVAREZ &amp; MARSAL</a:t>
+            </a:r>
+          </a:p>
+          <a:p>
+            <a:r>
+              <a:t>DTS · NIVELAMENTO IA</a:t>
+            </a:r>
+          </a:p>
+          <a:p>
+            <a:r>
+              <a:t>MURAL DO RETRATO FALADO</a:t>
+            </a:r>
+          </a:p>
+          <a:p>
+            <a:r>
+              <a:t>Bônus · Página 07 do caderno</a:t>
+            </a:r>
+          </a:p>
+          <a:p>
+            <a:r>
+              <a:t>Diagnóstico IA · DTS</a:t>
+            </a:r>
+          </a:p>
+          <a:p>
+            <a:r>
+              <a:t>5/5</a:t>
+            </a:r>
+          </a:p>
+          <a:p>
+            <a:r>
+              <a:t>RETRATO FALADO DTS · QUEM DESENHOU QUEM</a:t>
+            </a:r>
+          </a:p>
+          <a:p>
+            <a:r>
+              <a:t>Passe o mouse em cada caricatura</a:t>
             </a:r>
           </a:p>
           <a:p>
@@ -2872,6 +3045,16 @@
           <a:p>
             <a:r>
               <a:t>PALPITE</a:t>
+            </a:r>
+          </a:p>
+          <a:p>
+            <a:r>
+              <a:t>Fonte: prompts da página 07 do caderno · caricaturas geradas a partir das descrições do time</a:t>
+            </a:r>
+          </a:p>
+          <a:p>
+            <a:r>
+              <a:t>5/5</a:t>
             </a:r>
           </a:p>
         </p:txBody>
@@ -6027,6 +6210,48 @@
           </a:prstGeom>
         </p:spPr>
       </p:pic>
+    </p:spTree>
+  </p:cSld>
+  <p:clrMapOvr>
+    <a:masterClrMapping/>
+  </p:clrMapOvr>
+</p:sld>
+</file>
+
+<file path=ppt/slides/slide5.xml><?xml version="1.0" encoding="utf-8"?>
+<p:sld xmlns:a="http://schemas.openxmlformats.org/drawingml/2006/main" xmlns:p="http://schemas.openxmlformats.org/presentationml/2006/main" xmlns:r="http://schemas.openxmlformats.org/officeDocument/2006/relationships">
+  <p:cSld>
+    <p:spTree>
+      <p:nvGrpSpPr>
+        <p:cNvPr id="1" name=""/>
+        <p:cNvGrpSpPr/>
+        <p:nvPr/>
+      </p:nvGrpSpPr>
+      <p:grpSpPr/>
+      <p:pic>
+        <p:nvPicPr>
+          <p:cNvPr id="2" name="Picture 1" descr="s5.png"/>
+          <p:cNvPicPr>
+            <a:picLocks noChangeAspect="1"/>
+          </p:cNvPicPr>
+          <p:nvPr/>
+        </p:nvPicPr>
+        <p:blipFill>
+          <a:blip r:embed="rId2"/>
+          <a:stretch>
+            <a:fillRect/>
+          </a:stretch>
+        </p:blipFill>
+        <p:spPr>
+          <a:xfrm>
+            <a:off x="0" y="0"/>
+            <a:ext cx="12192000" cy="6858000"/>
+          </a:xfrm>
+          <a:prstGeom prst="rect">
+            <a:avLst/>
+          </a:prstGeom>
+        </p:spPr>
+      </p:pic>
       <p:sp>
         <p:nvSpPr>
           <p:cNvPr id="3" name="Rectangle 2">
@@ -6037,8 +6262,8 @@
         </p:nvSpPr>
         <p:spPr>
           <a:xfrm>
-            <a:off x="3329940" y="1021080"/>
-            <a:ext cx="2555200" cy="508635"/>
+            <a:off x="312420" y="2358390"/>
+            <a:ext cx="2674620" cy="495895"/>
           </a:xfrm>
           <a:prstGeom prst="rect">
             <a:avLst/>
@@ -6080,8 +6305,8 @@
         </p:nvSpPr>
         <p:spPr>
           <a:xfrm>
-            <a:off x="3329940" y="1605915"/>
-            <a:ext cx="2555200" cy="426720"/>
+            <a:off x="312420" y="2884765"/>
+            <a:ext cx="2674620" cy="495895"/>
           </a:xfrm>
           <a:prstGeom prst="rect">
             <a:avLst/>
@@ -6123,8 +6348,8 @@
         </p:nvSpPr>
         <p:spPr>
           <a:xfrm>
-            <a:off x="3329940" y="2108835"/>
-            <a:ext cx="2555200" cy="426720"/>
+            <a:off x="312420" y="3411140"/>
+            <a:ext cx="2674620" cy="626030"/>
           </a:xfrm>
           <a:prstGeom prst="rect">
             <a:avLst/>
@@ -6166,8 +6391,8 @@
         </p:nvSpPr>
         <p:spPr>
           <a:xfrm>
-            <a:off x="3329940" y="2611755"/>
-            <a:ext cx="2555200" cy="426720"/>
+            <a:off x="312420" y="4067651"/>
+            <a:ext cx="2674620" cy="495895"/>
           </a:xfrm>
           <a:prstGeom prst="rect">
             <a:avLst/>
@@ -6209,8 +6434,8 @@
         </p:nvSpPr>
         <p:spPr>
           <a:xfrm>
-            <a:off x="6266140" y="1021080"/>
-            <a:ext cx="2555200" cy="508635"/>
+            <a:off x="3276600" y="2358390"/>
+            <a:ext cx="2674620" cy="495895"/>
           </a:xfrm>
           <a:prstGeom prst="rect">
             <a:avLst/>
@@ -6252,8 +6477,8 @@
         </p:nvSpPr>
         <p:spPr>
           <a:xfrm>
-            <a:off x="6266140" y="1605915"/>
-            <a:ext cx="2555200" cy="426720"/>
+            <a:off x="3276600" y="2884765"/>
+            <a:ext cx="2674620" cy="495895"/>
           </a:xfrm>
           <a:prstGeom prst="rect">
             <a:avLst/>
@@ -6295,8 +6520,8 @@
         </p:nvSpPr>
         <p:spPr>
           <a:xfrm>
-            <a:off x="6266140" y="2108835"/>
-            <a:ext cx="2555200" cy="508635"/>
+            <a:off x="3276600" y="3411140"/>
+            <a:ext cx="2674620" cy="495895"/>
           </a:xfrm>
           <a:prstGeom prst="rect">
             <a:avLst/>
@@ -6338,8 +6563,8 @@
         </p:nvSpPr>
         <p:spPr>
           <a:xfrm>
-            <a:off x="6266140" y="2693670"/>
-            <a:ext cx="2555200" cy="426720"/>
+            <a:off x="3276600" y="3937515"/>
+            <a:ext cx="2674620" cy="495895"/>
           </a:xfrm>
           <a:prstGeom prst="rect">
             <a:avLst/>
@@ -6381,8 +6606,8 @@
         </p:nvSpPr>
         <p:spPr>
           <a:xfrm>
-            <a:off x="9202340" y="1021080"/>
-            <a:ext cx="2555319" cy="508635"/>
+            <a:off x="6240780" y="2358390"/>
+            <a:ext cx="2674620" cy="495895"/>
           </a:xfrm>
           <a:prstGeom prst="rect">
             <a:avLst/>
@@ -6424,8 +6649,8 @@
         </p:nvSpPr>
         <p:spPr>
           <a:xfrm>
-            <a:off x="9202340" y="1605915"/>
-            <a:ext cx="2555319" cy="508635"/>
+            <a:off x="6240780" y="2884765"/>
+            <a:ext cx="2674620" cy="495895"/>
           </a:xfrm>
           <a:prstGeom prst="rect">
             <a:avLst/>
@@ -6467,8 +6692,8 @@
         </p:nvSpPr>
         <p:spPr>
           <a:xfrm>
-            <a:off x="9202340" y="2190750"/>
-            <a:ext cx="2555319" cy="426720"/>
+            <a:off x="6240780" y="3411140"/>
+            <a:ext cx="2674620" cy="495895"/>
           </a:xfrm>
           <a:prstGeom prst="rect">
             <a:avLst/>
@@ -6510,8 +6735,8 @@
         </p:nvSpPr>
         <p:spPr>
           <a:xfrm>
-            <a:off x="9202340" y="2693670"/>
-            <a:ext cx="2555319" cy="426720"/>
+            <a:off x="6240780" y="3937515"/>
+            <a:ext cx="2674620" cy="626030"/>
           </a:xfrm>
           <a:prstGeom prst="rect">
             <a:avLst/>
@@ -6553,8 +6778,8 @@
         </p:nvSpPr>
         <p:spPr>
           <a:xfrm>
-            <a:off x="4893468" y="6195060"/>
-            <a:ext cx="6856571" cy="182880"/>
+            <a:off x="9204960" y="2358390"/>
+            <a:ext cx="2674620" cy="495895"/>
           </a:xfrm>
           <a:prstGeom prst="rect">
             <a:avLst/>
@@ -6586,6 +6811,178 @@
           </a:p>
         </p:txBody>
       </p:sp>
+      <p:sp>
+        <p:nvSpPr>
+          <p:cNvPr id="16" name="Rectangle 15">
+            <a:hlinkClick r:id="rId16"/>
+          </p:cNvPr>
+          <p:cNvSpPr/>
+          <p:nvPr/>
+        </p:nvSpPr>
+        <p:spPr>
+          <a:xfrm>
+            <a:off x="9204960" y="2884765"/>
+            <a:ext cx="2674620" cy="495895"/>
+          </a:xfrm>
+          <a:prstGeom prst="rect">
+            <a:avLst/>
+          </a:prstGeom>
+          <a:noFill/>
+          <a:ln>
+            <a:noFill/>
+          </a:ln>
+        </p:spPr>
+        <p:style>
+          <a:lnRef idx="1">
+            <a:schemeClr val="accent1"/>
+          </a:lnRef>
+          <a:fillRef idx="3">
+            <a:schemeClr val="accent1"/>
+          </a:fillRef>
+          <a:effectRef idx="2">
+            <a:schemeClr val="accent1"/>
+          </a:effectRef>
+          <a:fontRef idx="minor">
+            <a:schemeClr val="lt1"/>
+          </a:fontRef>
+        </p:style>
+        <p:txBody>
+          <a:bodyPr rtlCol="0" anchor="ctr"/>
+          <a:lstStyle/>
+          <a:p>
+            <a:pPr algn="ctr"/>
+          </a:p>
+        </p:txBody>
+      </p:sp>
+      <p:sp>
+        <p:nvSpPr>
+          <p:cNvPr id="17" name="Rectangle 16">
+            <a:hlinkClick r:id="rId17"/>
+          </p:cNvPr>
+          <p:cNvSpPr/>
+          <p:nvPr/>
+        </p:nvSpPr>
+        <p:spPr>
+          <a:xfrm>
+            <a:off x="9204960" y="3411140"/>
+            <a:ext cx="2674620" cy="495895"/>
+          </a:xfrm>
+          <a:prstGeom prst="rect">
+            <a:avLst/>
+          </a:prstGeom>
+          <a:noFill/>
+          <a:ln>
+            <a:noFill/>
+          </a:ln>
+        </p:spPr>
+        <p:style>
+          <a:lnRef idx="1">
+            <a:schemeClr val="accent1"/>
+          </a:lnRef>
+          <a:fillRef idx="3">
+            <a:schemeClr val="accent1"/>
+          </a:fillRef>
+          <a:effectRef idx="2">
+            <a:schemeClr val="accent1"/>
+          </a:effectRef>
+          <a:fontRef idx="minor">
+            <a:schemeClr val="lt1"/>
+          </a:fontRef>
+        </p:style>
+        <p:txBody>
+          <a:bodyPr rtlCol="0" anchor="ctr"/>
+          <a:lstStyle/>
+          <a:p>
+            <a:pPr algn="ctr"/>
+          </a:p>
+        </p:txBody>
+      </p:sp>
+      <p:sp>
+        <p:nvSpPr>
+          <p:cNvPr id="18" name="Rectangle 17">
+            <a:hlinkClick r:id="rId18"/>
+          </p:cNvPr>
+          <p:cNvSpPr/>
+          <p:nvPr/>
+        </p:nvSpPr>
+        <p:spPr>
+          <a:xfrm>
+            <a:off x="9204960" y="3937515"/>
+            <a:ext cx="2674620" cy="495895"/>
+          </a:xfrm>
+          <a:prstGeom prst="rect">
+            <a:avLst/>
+          </a:prstGeom>
+          <a:noFill/>
+          <a:ln>
+            <a:noFill/>
+          </a:ln>
+        </p:spPr>
+        <p:style>
+          <a:lnRef idx="1">
+            <a:schemeClr val="accent1"/>
+          </a:lnRef>
+          <a:fillRef idx="3">
+            <a:schemeClr val="accent1"/>
+          </a:fillRef>
+          <a:effectRef idx="2">
+            <a:schemeClr val="accent1"/>
+          </a:effectRef>
+          <a:fontRef idx="minor">
+            <a:schemeClr val="lt1"/>
+          </a:fontRef>
+        </p:style>
+        <p:txBody>
+          <a:bodyPr rtlCol="0" anchor="ctr"/>
+          <a:lstStyle/>
+          <a:p>
+            <a:pPr algn="ctr"/>
+          </a:p>
+        </p:txBody>
+      </p:sp>
+      <p:sp>
+        <p:nvSpPr>
+          <p:cNvPr id="19" name="Rectangle 18">
+            <a:hlinkClick r:id="rId19"/>
+          </p:cNvPr>
+          <p:cNvSpPr/>
+          <p:nvPr/>
+        </p:nvSpPr>
+        <p:spPr>
+          <a:xfrm>
+            <a:off x="1429464" y="6301740"/>
+            <a:ext cx="8476535" cy="152400"/>
+          </a:xfrm>
+          <a:prstGeom prst="rect">
+            <a:avLst/>
+          </a:prstGeom>
+          <a:noFill/>
+          <a:ln>
+            <a:noFill/>
+          </a:ln>
+        </p:spPr>
+        <p:style>
+          <a:lnRef idx="1">
+            <a:schemeClr val="accent1"/>
+          </a:lnRef>
+          <a:fillRef idx="3">
+            <a:schemeClr val="accent1"/>
+          </a:fillRef>
+          <a:effectRef idx="2">
+            <a:schemeClr val="accent1"/>
+          </a:effectRef>
+          <a:fontRef idx="minor">
+            <a:schemeClr val="lt1"/>
+          </a:fontRef>
+        </p:style>
+        <p:txBody>
+          <a:bodyPr rtlCol="0" anchor="ctr"/>
+          <a:lstStyle/>
+          <a:p>
+            <a:pPr algn="ctr"/>
+          </a:p>
+        </p:txBody>
+      </p:sp>
     </p:spTree>
   </p:cSld>
   <p:clrMapOvr>
@@ -6594,7 +6991,7 @@
 </p:sld>
 </file>
 
-<file path=ppt/slides/slide5.xml><?xml version="1.0" encoding="utf-8"?>
+<file path=ppt/slides/slide6.xml><?xml version="1.0" encoding="utf-8"?>
 <p:sld xmlns:a="http://schemas.openxmlformats.org/drawingml/2006/main" xmlns:p="http://schemas.openxmlformats.org/presentationml/2006/main" xmlns:r="http://schemas.openxmlformats.org/officeDocument/2006/relationships">
   <p:cSld>
     <p:spTree>
@@ -6606,7 +7003,7 @@
       <p:grpSpPr/>
       <p:pic>
         <p:nvPicPr>
-          <p:cNvPr id="2" name="Picture 1" descr="s5.png"/>
+          <p:cNvPr id="2" name="Picture 1" descr="s6.png"/>
           <p:cNvPicPr>
             <a:picLocks noChangeAspect="1"/>
           </p:cNvPicPr>

</xml_diff>